<commit_message>
Improve TEMG 3950 W11 assignment
Signed-off-by: William So <polyipseity@gmail.com>
Private-commit: fbccadeba925355a67e2f7331b525b44140433ec
</commit_message>
<xml_diff>
--- a/special/academia/HKUST/TEMG 3950/assignment W11/W11 Organizational Analysis (DRW).pptx
+++ b/special/academia/HKUST/TEMG 3950/assignment W11/W11 Organizational Analysis (DRW).pptx
@@ -4302,10 +4302,10 @@
       </p:sp>
       <p:sp>
         <p:nvSpPr>
-          <p:cNvPr id="88" name="Rectangle: Rounded Corners 87">
-            <a:extLst>
-              <a:ext uri="{FF2B5EF4-FFF2-40B4-BE49-F238E27FC236}">
-                <a16:creationId xmlns:a16="http://schemas.microsoft.com/office/drawing/2014/main" id="{96C75B9F-FAE4-0474-2BCE-D48925D09686}"/>
+          <p:cNvPr id="98" name="Rectangle: Rounded Corners 97">
+            <a:extLst>
+              <a:ext uri="{FF2B5EF4-FFF2-40B4-BE49-F238E27FC236}">
+                <a16:creationId xmlns:a16="http://schemas.microsoft.com/office/drawing/2014/main" id="{8F7D9169-CB5E-C6A1-16AE-EE6B1A023471}"/>
               </a:ext>
             </a:extLst>
           </p:cNvPr>
@@ -4314,8 +4314,8 @@
         </p:nvSpPr>
         <p:spPr>
           <a:xfrm>
-            <a:off x="10990649" y="655385"/>
-            <a:ext cx="860600" cy="329926"/>
+            <a:off x="2992698" y="1875427"/>
+            <a:ext cx="880535" cy="389903"/>
           </a:xfrm>
           <a:prstGeom prst="roundRect">
             <a:avLst/>
@@ -4341,19 +4341,19 @@
           <a:p>
             <a:pPr algn="ctr"/>
             <a:r>
-              <a:rPr lang="en-US" altLang="zh-HK" sz="1400" dirty="0"/>
-              <a:t>Element</a:t>
-            </a:r>
-            <a:endParaRPr lang="zh-HK" altLang="en-US" sz="1400" dirty="0"/>
-          </a:p>
-        </p:txBody>
-      </p:sp>
-      <p:sp>
-        <p:nvSpPr>
-          <p:cNvPr id="90" name="Rectangle: Rounded Corners 89">
-            <a:extLst>
-              <a:ext uri="{FF2B5EF4-FFF2-40B4-BE49-F238E27FC236}">
-                <a16:creationId xmlns:a16="http://schemas.microsoft.com/office/drawing/2014/main" id="{72BDDE57-BA92-8F8D-E3DF-186CF3E5570B}"/>
+              <a:rPr lang="en-US" altLang="zh-HK" sz="800" dirty="0"/>
+              <a:t>Contracts are time-sensitive</a:t>
+            </a:r>
+            <a:endParaRPr lang="zh-HK" altLang="en-US" sz="800" dirty="0"/>
+          </a:p>
+        </p:txBody>
+      </p:sp>
+      <p:sp>
+        <p:nvSpPr>
+          <p:cNvPr id="100" name="Rectangle: Rounded Corners 99">
+            <a:extLst>
+              <a:ext uri="{FF2B5EF4-FFF2-40B4-BE49-F238E27FC236}">
+                <a16:creationId xmlns:a16="http://schemas.microsoft.com/office/drawing/2014/main" id="{84FBBDF9-0313-5B7E-E3D0-D1506A25E3D1}"/>
               </a:ext>
             </a:extLst>
           </p:cNvPr>
@@ -4362,18 +4362,12 @@
         </p:nvSpPr>
         <p:spPr>
           <a:xfrm>
-            <a:off x="10990766" y="344231"/>
-            <a:ext cx="881137" cy="361419"/>
+            <a:off x="2942766" y="2855031"/>
+            <a:ext cx="1207107" cy="491534"/>
           </a:xfrm>
           <a:prstGeom prst="roundRect">
             <a:avLst/>
           </a:prstGeom>
-          <a:solidFill>
-            <a:schemeClr val="accent6">
-              <a:lumMod val="60000"/>
-              <a:lumOff val="40000"/>
-            </a:schemeClr>
-          </a:solidFill>
         </p:spPr>
         <p:style>
           <a:lnRef idx="2">
@@ -4395,19 +4389,19 @@
           <a:p>
             <a:pPr algn="ctr"/>
             <a:r>
-              <a:rPr lang="en-US" altLang="zh-HK" sz="1400" dirty="0"/>
-              <a:t>Solution</a:t>
-            </a:r>
-            <a:endParaRPr lang="zh-HK" altLang="en-US" sz="1400" dirty="0"/>
-          </a:p>
-        </p:txBody>
-      </p:sp>
-      <p:sp>
-        <p:nvSpPr>
-          <p:cNvPr id="92" name="Rectangle: Rounded Corners 91">
-            <a:extLst>
-              <a:ext uri="{FF2B5EF4-FFF2-40B4-BE49-F238E27FC236}">
-                <a16:creationId xmlns:a16="http://schemas.microsoft.com/office/drawing/2014/main" id="{5D68D801-7867-9272-B71A-9D43B9B0FCD9}"/>
+              <a:rPr lang="en-US" altLang="zh-HK" sz="800" dirty="0"/>
+              <a:t>Wrong person is hired for the position in the company</a:t>
+            </a:r>
+            <a:endParaRPr lang="zh-HK" altLang="en-US" sz="800" dirty="0"/>
+          </a:p>
+        </p:txBody>
+      </p:sp>
+      <p:sp>
+        <p:nvSpPr>
+          <p:cNvPr id="102" name="Rectangle: Rounded Corners 101">
+            <a:extLst>
+              <a:ext uri="{FF2B5EF4-FFF2-40B4-BE49-F238E27FC236}">
+                <a16:creationId xmlns:a16="http://schemas.microsoft.com/office/drawing/2014/main" id="{5C17D2D9-6742-4667-79B6-E1A31F9825A3}"/>
               </a:ext>
             </a:extLst>
           </p:cNvPr>
@@ -4416,14 +4410,14 @@
         </p:nvSpPr>
         <p:spPr>
           <a:xfrm>
-            <a:off x="10962342" y="937685"/>
-            <a:ext cx="966218" cy="339980"/>
+            <a:off x="100996" y="1746553"/>
+            <a:ext cx="1031118" cy="653142"/>
           </a:xfrm>
           <a:prstGeom prst="roundRect">
             <a:avLst/>
           </a:prstGeom>
           <a:solidFill>
-            <a:srgbClr val="FFCCFF"/>
+            <a:srgbClr val="FF0000"/>
           </a:solidFill>
         </p:spPr>
         <p:style>
@@ -4446,19 +4440,27 @@
           <a:p>
             <a:pPr algn="ctr"/>
             <a:r>
-              <a:rPr lang="en-US" altLang="zh-HK" sz="1400" dirty="0"/>
-              <a:t>Evidence</a:t>
-            </a:r>
-            <a:endParaRPr lang="zh-HK" altLang="en-US" sz="1400" dirty="0"/>
-          </a:p>
-        </p:txBody>
-      </p:sp>
-      <p:sp>
-        <p:nvSpPr>
-          <p:cNvPr id="98" name="Rectangle: Rounded Corners 97">
-            <a:extLst>
-              <a:ext uri="{FF2B5EF4-FFF2-40B4-BE49-F238E27FC236}">
-                <a16:creationId xmlns:a16="http://schemas.microsoft.com/office/drawing/2014/main" id="{8F7D9169-CB5E-C6A1-16AE-EE6B1A023471}"/>
+              <a:rPr lang="en-US" altLang="zh-HK" sz="800" dirty="0">
+                <a:solidFill>
+                  <a:schemeClr val="bg1"/>
+                </a:solidFill>
+              </a:rPr>
+              <a:t>Failure of implementing new procurement policy</a:t>
+            </a:r>
+            <a:endParaRPr lang="zh-HK" altLang="en-US" sz="800" dirty="0">
+              <a:solidFill>
+                <a:schemeClr val="bg1"/>
+              </a:solidFill>
+            </a:endParaRPr>
+          </a:p>
+        </p:txBody>
+      </p:sp>
+      <p:sp>
+        <p:nvSpPr>
+          <p:cNvPr id="104" name="Rectangle: Rounded Corners 103">
+            <a:extLst>
+              <a:ext uri="{FF2B5EF4-FFF2-40B4-BE49-F238E27FC236}">
+                <a16:creationId xmlns:a16="http://schemas.microsoft.com/office/drawing/2014/main" id="{85110D37-45D2-E996-4BBE-CD8A88ACE713}"/>
               </a:ext>
             </a:extLst>
           </p:cNvPr>
@@ -4467,8 +4469,8 @@
         </p:nvSpPr>
         <p:spPr>
           <a:xfrm>
-            <a:off x="2992698" y="1875427"/>
-            <a:ext cx="880535" cy="389903"/>
+            <a:off x="1313541" y="1821075"/>
+            <a:ext cx="1207107" cy="491534"/>
           </a:xfrm>
           <a:prstGeom prst="roundRect">
             <a:avLst/>
@@ -4495,7 +4497,7 @@
             <a:pPr algn="ctr"/>
             <a:r>
               <a:rPr lang="en-US" altLang="zh-HK" sz="800" dirty="0"/>
-              <a:t>Contracts are time-sensitive</a:t>
+              <a:t>Plant managers not reporting contracts over $250k in advance of 2 weeks</a:t>
             </a:r>
             <a:endParaRPr lang="zh-HK" altLang="en-US" sz="800" dirty="0"/>
           </a:p>
@@ -4503,10 +4505,10 @@
       </p:sp>
       <p:sp>
         <p:nvSpPr>
-          <p:cNvPr id="100" name="Rectangle: Rounded Corners 99">
-            <a:extLst>
-              <a:ext uri="{FF2B5EF4-FFF2-40B4-BE49-F238E27FC236}">
-                <a16:creationId xmlns:a16="http://schemas.microsoft.com/office/drawing/2014/main" id="{84FBBDF9-0313-5B7E-E3D0-D1506A25E3D1}"/>
+          <p:cNvPr id="110" name="Rectangle: Rounded Corners 109">
+            <a:extLst>
+              <a:ext uri="{FF2B5EF4-FFF2-40B4-BE49-F238E27FC236}">
+                <a16:creationId xmlns:a16="http://schemas.microsoft.com/office/drawing/2014/main" id="{B84F5C11-CEAD-7B93-0CC5-24716CDD5A03}"/>
               </a:ext>
             </a:extLst>
           </p:cNvPr>
@@ -4515,7 +4517,7 @@
         </p:nvSpPr>
         <p:spPr>
           <a:xfrm>
-            <a:off x="2942766" y="2855031"/>
+            <a:off x="2942766" y="4949714"/>
             <a:ext cx="1207107" cy="491534"/>
           </a:xfrm>
           <a:prstGeom prst="roundRect">
@@ -4543,7 +4545,7 @@
             <a:pPr algn="ctr"/>
             <a:r>
               <a:rPr lang="en-US" altLang="zh-HK" sz="800" dirty="0"/>
-              <a:t>Wrong person is hired for the position in the company</a:t>
+              <a:t>Ed Claiborne has not adapted to the company management culture</a:t>
             </a:r>
             <a:endParaRPr lang="zh-HK" altLang="en-US" sz="800" dirty="0"/>
           </a:p>
@@ -4551,10 +4553,10 @@
       </p:sp>
       <p:sp>
         <p:nvSpPr>
-          <p:cNvPr id="102" name="Rectangle: Rounded Corners 101">
-            <a:extLst>
-              <a:ext uri="{FF2B5EF4-FFF2-40B4-BE49-F238E27FC236}">
-                <a16:creationId xmlns:a16="http://schemas.microsoft.com/office/drawing/2014/main" id="{5C17D2D9-6742-4667-79B6-E1A31F9825A3}"/>
+          <p:cNvPr id="112" name="Rectangle: Rounded Corners 111">
+            <a:extLst>
+              <a:ext uri="{FF2B5EF4-FFF2-40B4-BE49-F238E27FC236}">
+                <a16:creationId xmlns:a16="http://schemas.microsoft.com/office/drawing/2014/main" id="{1D7328F4-215F-B1C8-BDF2-9E1609B2CB72}"/>
               </a:ext>
             </a:extLst>
           </p:cNvPr>
@@ -4563,15 +4565,12 @@
         </p:nvSpPr>
         <p:spPr>
           <a:xfrm>
-            <a:off x="100996" y="1746553"/>
-            <a:ext cx="1031118" cy="653142"/>
+            <a:off x="4515689" y="1706509"/>
+            <a:ext cx="1524297" cy="207912"/>
           </a:xfrm>
           <a:prstGeom prst="roundRect">
             <a:avLst/>
           </a:prstGeom>
-          <a:solidFill>
-            <a:srgbClr val="FF0000"/>
-          </a:solidFill>
         </p:spPr>
         <p:style>
           <a:lnRef idx="2">
@@ -4593,27 +4592,19 @@
           <a:p>
             <a:pPr algn="ctr"/>
             <a:r>
-              <a:rPr lang="en-US" altLang="zh-HK" sz="800" dirty="0">
-                <a:solidFill>
-                  <a:schemeClr val="bg1"/>
-                </a:solidFill>
-              </a:rPr>
-              <a:t>Failure of implementing new procurement policy</a:t>
-            </a:r>
-            <a:endParaRPr lang="zh-HK" altLang="en-US" sz="800" dirty="0">
-              <a:solidFill>
-                <a:schemeClr val="bg1"/>
-              </a:solidFill>
-            </a:endParaRPr>
-          </a:p>
-        </p:txBody>
-      </p:sp>
-      <p:sp>
-        <p:nvSpPr>
-          <p:cNvPr id="104" name="Rectangle: Rounded Corners 103">
-            <a:extLst>
-              <a:ext uri="{FF2B5EF4-FFF2-40B4-BE49-F238E27FC236}">
-                <a16:creationId xmlns:a16="http://schemas.microsoft.com/office/drawing/2014/main" id="{85110D37-45D2-E996-4BBE-CD8A88ACE713}"/>
+              <a:rPr lang="en-US" altLang="zh-HK" sz="800" dirty="0"/>
+              <a:t>There are external rush orders</a:t>
+            </a:r>
+            <a:endParaRPr lang="zh-HK" altLang="en-US" sz="800" dirty="0"/>
+          </a:p>
+        </p:txBody>
+      </p:sp>
+      <p:sp>
+        <p:nvSpPr>
+          <p:cNvPr id="113" name="Rectangle: Rounded Corners 112">
+            <a:extLst>
+              <a:ext uri="{FF2B5EF4-FFF2-40B4-BE49-F238E27FC236}">
+                <a16:creationId xmlns:a16="http://schemas.microsoft.com/office/drawing/2014/main" id="{66524575-FD5A-F4FC-F9D1-ED1192E6DAAB}"/>
               </a:ext>
             </a:extLst>
           </p:cNvPr>
@@ -4622,8 +4613,8 @@
         </p:nvSpPr>
         <p:spPr>
           <a:xfrm>
-            <a:off x="1313541" y="1821075"/>
-            <a:ext cx="1207107" cy="491534"/>
+            <a:off x="7459346" y="1664377"/>
+            <a:ext cx="1427247" cy="389903"/>
           </a:xfrm>
           <a:prstGeom prst="roundRect">
             <a:avLst/>
@@ -4650,7 +4641,7 @@
             <a:pPr algn="ctr"/>
             <a:r>
               <a:rPr lang="en-US" altLang="zh-HK" sz="800" dirty="0"/>
-              <a:t>Plant managers not reporting contracts over $250k in advance of 2 weeks</a:t>
+              <a:t>External rush orders are by high-priority customers</a:t>
             </a:r>
             <a:endParaRPr lang="zh-HK" altLang="en-US" sz="800" dirty="0"/>
           </a:p>
@@ -4658,10 +4649,10 @@
       </p:sp>
       <p:sp>
         <p:nvSpPr>
-          <p:cNvPr id="110" name="Rectangle: Rounded Corners 109">
-            <a:extLst>
-              <a:ext uri="{FF2B5EF4-FFF2-40B4-BE49-F238E27FC236}">
-                <a16:creationId xmlns:a16="http://schemas.microsoft.com/office/drawing/2014/main" id="{B84F5C11-CEAD-7B93-0CC5-24716CDD5A03}"/>
+          <p:cNvPr id="114" name="Rectangle: Rounded Corners 113">
+            <a:extLst>
+              <a:ext uri="{FF2B5EF4-FFF2-40B4-BE49-F238E27FC236}">
+                <a16:creationId xmlns:a16="http://schemas.microsoft.com/office/drawing/2014/main" id="{ECD1BE1A-7710-0EAC-DE74-E295C7691F39}"/>
               </a:ext>
             </a:extLst>
           </p:cNvPr>
@@ -4670,8 +4661,8 @@
         </p:nvSpPr>
         <p:spPr>
           <a:xfrm>
-            <a:off x="2942766" y="4949714"/>
-            <a:ext cx="1207107" cy="491534"/>
+            <a:off x="7483923" y="2085807"/>
+            <a:ext cx="1427247" cy="397318"/>
           </a:xfrm>
           <a:prstGeom prst="roundRect">
             <a:avLst/>
@@ -4698,7 +4689,7 @@
             <a:pPr algn="ctr"/>
             <a:r>
               <a:rPr lang="en-US" altLang="zh-HK" sz="800" dirty="0"/>
-              <a:t>Ed Claiborne has not adapted to the company management culture</a:t>
+              <a:t>Maintain relationships with high-priority customers</a:t>
             </a:r>
             <a:endParaRPr lang="zh-HK" altLang="en-US" sz="800" dirty="0"/>
           </a:p>
@@ -4706,10 +4697,10 @@
       </p:sp>
       <p:sp>
         <p:nvSpPr>
-          <p:cNvPr id="112" name="Rectangle: Rounded Corners 111">
-            <a:extLst>
-              <a:ext uri="{FF2B5EF4-FFF2-40B4-BE49-F238E27FC236}">
-                <a16:creationId xmlns:a16="http://schemas.microsoft.com/office/drawing/2014/main" id="{1D7328F4-215F-B1C8-BDF2-9E1609B2CB72}"/>
+          <p:cNvPr id="115" name="Rectangle: Rounded Corners 114">
+            <a:extLst>
+              <a:ext uri="{FF2B5EF4-FFF2-40B4-BE49-F238E27FC236}">
+                <a16:creationId xmlns:a16="http://schemas.microsoft.com/office/drawing/2014/main" id="{B6B66BB5-7C4B-EA39-FE1A-C953837D71DD}"/>
               </a:ext>
             </a:extLst>
           </p:cNvPr>
@@ -4718,8 +4709,8 @@
         </p:nvSpPr>
         <p:spPr>
           <a:xfrm>
-            <a:off x="4515689" y="1706509"/>
-            <a:ext cx="1524297" cy="207912"/>
+            <a:off x="9941082" y="2081501"/>
+            <a:ext cx="880535" cy="389903"/>
           </a:xfrm>
           <a:prstGeom prst="roundRect">
             <a:avLst/>
@@ -4746,7 +4737,7 @@
             <a:pPr algn="ctr"/>
             <a:r>
               <a:rPr lang="en-US" altLang="zh-HK" sz="800" dirty="0"/>
-              <a:t>There are external rush orders</a:t>
+              <a:t>To retain loyal customers</a:t>
             </a:r>
             <a:endParaRPr lang="zh-HK" altLang="en-US" sz="800" dirty="0"/>
           </a:p>
@@ -4754,10 +4745,10 @@
       </p:sp>
       <p:sp>
         <p:nvSpPr>
-          <p:cNvPr id="113" name="Rectangle: Rounded Corners 112">
-            <a:extLst>
-              <a:ext uri="{FF2B5EF4-FFF2-40B4-BE49-F238E27FC236}">
-                <a16:creationId xmlns:a16="http://schemas.microsoft.com/office/drawing/2014/main" id="{66524575-FD5A-F4FC-F9D1-ED1192E6DAAB}"/>
+          <p:cNvPr id="116" name="Rectangle: Rounded Corners 115">
+            <a:extLst>
+              <a:ext uri="{FF2B5EF4-FFF2-40B4-BE49-F238E27FC236}">
+                <a16:creationId xmlns:a16="http://schemas.microsoft.com/office/drawing/2014/main" id="{38CF36CF-6EDE-4DC1-025D-50CC2E892D66}"/>
               </a:ext>
             </a:extLst>
           </p:cNvPr>
@@ -4766,8 +4757,8 @@
         </p:nvSpPr>
         <p:spPr>
           <a:xfrm>
-            <a:off x="7459346" y="1664377"/>
-            <a:ext cx="1427247" cy="389903"/>
+            <a:off x="4614914" y="2839641"/>
+            <a:ext cx="1554423" cy="492760"/>
           </a:xfrm>
           <a:prstGeom prst="roundRect">
             <a:avLst/>
@@ -4794,7 +4785,7 @@
             <a:pPr algn="ctr"/>
             <a:r>
               <a:rPr lang="en-US" altLang="zh-HK" sz="800" dirty="0"/>
-              <a:t>External rush orders are by high-priority customers</a:t>
+              <a:t>Ed Claiborne is not the most suitable for the position in the company</a:t>
             </a:r>
             <a:endParaRPr lang="zh-HK" altLang="en-US" sz="800" dirty="0"/>
           </a:p>
@@ -4802,10 +4793,10 @@
       </p:sp>
       <p:sp>
         <p:nvSpPr>
-          <p:cNvPr id="114" name="Rectangle: Rounded Corners 113">
-            <a:extLst>
-              <a:ext uri="{FF2B5EF4-FFF2-40B4-BE49-F238E27FC236}">
-                <a16:creationId xmlns:a16="http://schemas.microsoft.com/office/drawing/2014/main" id="{ECD1BE1A-7710-0EAC-DE74-E295C7691F39}"/>
+          <p:cNvPr id="117" name="Rectangle: Rounded Corners 116">
+            <a:extLst>
+              <a:ext uri="{FF2B5EF4-FFF2-40B4-BE49-F238E27FC236}">
+                <a16:creationId xmlns:a16="http://schemas.microsoft.com/office/drawing/2014/main" id="{7DEC2B59-5C8E-BE87-DC63-1C4B884F2180}"/>
               </a:ext>
             </a:extLst>
           </p:cNvPr>
@@ -4814,8 +4805,8 @@
         </p:nvSpPr>
         <p:spPr>
           <a:xfrm>
-            <a:off x="7483923" y="2085807"/>
-            <a:ext cx="1427247" cy="397318"/>
+            <a:off x="4614914" y="4212143"/>
+            <a:ext cx="2205298" cy="301789"/>
           </a:xfrm>
           <a:prstGeom prst="roundRect">
             <a:avLst/>
@@ -4842,7 +4833,7 @@
             <a:pPr algn="ctr"/>
             <a:r>
               <a:rPr lang="en-US" altLang="zh-HK" sz="800" dirty="0"/>
-              <a:t>Maintain relationships with high-priority customers</a:t>
+              <a:t>Dagmar Hilgard did not consider hiring Ed Claiborne thoroughly</a:t>
             </a:r>
             <a:endParaRPr lang="zh-HK" altLang="en-US" sz="800" dirty="0"/>
           </a:p>
@@ -4850,10 +4841,10 @@
       </p:sp>
       <p:sp>
         <p:nvSpPr>
-          <p:cNvPr id="115" name="Rectangle: Rounded Corners 114">
-            <a:extLst>
-              <a:ext uri="{FF2B5EF4-FFF2-40B4-BE49-F238E27FC236}">
-                <a16:creationId xmlns:a16="http://schemas.microsoft.com/office/drawing/2014/main" id="{B6B66BB5-7C4B-EA39-FE1A-C953837D71DD}"/>
+          <p:cNvPr id="118" name="Rectangle: Rounded Corners 117">
+            <a:extLst>
+              <a:ext uri="{FF2B5EF4-FFF2-40B4-BE49-F238E27FC236}">
+                <a16:creationId xmlns:a16="http://schemas.microsoft.com/office/drawing/2014/main" id="{5775E6F8-A610-FDB8-6F1F-DF52722F0918}"/>
               </a:ext>
             </a:extLst>
           </p:cNvPr>
@@ -4862,8 +4853,8 @@
         </p:nvSpPr>
         <p:spPr>
           <a:xfrm>
-            <a:off x="9941082" y="2081501"/>
-            <a:ext cx="880535" cy="389903"/>
+            <a:off x="7440990" y="2894841"/>
+            <a:ext cx="1101885" cy="389904"/>
           </a:xfrm>
           <a:prstGeom prst="roundRect">
             <a:avLst/>
@@ -4890,7 +4881,7 @@
             <a:pPr algn="ctr"/>
             <a:r>
               <a:rPr lang="en-US" altLang="zh-HK" sz="800" dirty="0"/>
-              <a:t>To retain loyal customers</a:t>
+              <a:t>The company chain of command is lax</a:t>
             </a:r>
             <a:endParaRPr lang="zh-HK" altLang="en-US" sz="800" dirty="0"/>
           </a:p>
@@ -4898,10 +4889,10 @@
       </p:sp>
       <p:sp>
         <p:nvSpPr>
-          <p:cNvPr id="116" name="Rectangle: Rounded Corners 115">
-            <a:extLst>
-              <a:ext uri="{FF2B5EF4-FFF2-40B4-BE49-F238E27FC236}">
-                <a16:creationId xmlns:a16="http://schemas.microsoft.com/office/drawing/2014/main" id="{38CF36CF-6EDE-4DC1-025D-50CC2E892D66}"/>
+          <p:cNvPr id="119" name="Rectangle: Rounded Corners 118">
+            <a:extLst>
+              <a:ext uri="{FF2B5EF4-FFF2-40B4-BE49-F238E27FC236}">
+                <a16:creationId xmlns:a16="http://schemas.microsoft.com/office/drawing/2014/main" id="{8CD2C558-5EF9-515D-DBB9-BB21E0DC386D}"/>
               </a:ext>
             </a:extLst>
           </p:cNvPr>
@@ -4910,8 +4901,8 @@
         </p:nvSpPr>
         <p:spPr>
           <a:xfrm>
-            <a:off x="4614914" y="2839641"/>
-            <a:ext cx="1554423" cy="492760"/>
+            <a:off x="7511745" y="3351438"/>
+            <a:ext cx="1207107" cy="491534"/>
           </a:xfrm>
           <a:prstGeom prst="roundRect">
             <a:avLst/>
@@ -4938,7 +4929,7 @@
             <a:pPr algn="ctr"/>
             <a:r>
               <a:rPr lang="en-US" altLang="zh-HK" sz="800" dirty="0"/>
-              <a:t>Ed Claiborne is not the most suitable for the position in the company</a:t>
+              <a:t>Ed Claiborne had been working for a firm with a strict chain of command</a:t>
             </a:r>
             <a:endParaRPr lang="zh-HK" altLang="en-US" sz="800" dirty="0"/>
           </a:p>
@@ -4946,10 +4937,10 @@
       </p:sp>
       <p:sp>
         <p:nvSpPr>
-          <p:cNvPr id="117" name="Rectangle: Rounded Corners 116">
-            <a:extLst>
-              <a:ext uri="{FF2B5EF4-FFF2-40B4-BE49-F238E27FC236}">
-                <a16:creationId xmlns:a16="http://schemas.microsoft.com/office/drawing/2014/main" id="{7DEC2B59-5C8E-BE87-DC63-1C4B884F2180}"/>
+          <p:cNvPr id="120" name="Rectangle: Rounded Corners 119">
+            <a:extLst>
+              <a:ext uri="{FF2B5EF4-FFF2-40B4-BE49-F238E27FC236}">
+                <a16:creationId xmlns:a16="http://schemas.microsoft.com/office/drawing/2014/main" id="{41E5EA84-36E1-4ABF-F9E5-064621B3D65C}"/>
               </a:ext>
             </a:extLst>
           </p:cNvPr>
@@ -4958,8 +4949,8 @@
         </p:nvSpPr>
         <p:spPr>
           <a:xfrm>
-            <a:off x="4614914" y="4212143"/>
-            <a:ext cx="2205298" cy="301789"/>
+            <a:off x="7445085" y="4081807"/>
+            <a:ext cx="1427247" cy="563318"/>
           </a:xfrm>
           <a:prstGeom prst="roundRect">
             <a:avLst/>
@@ -4986,7 +4977,7 @@
             <a:pPr algn="ctr"/>
             <a:r>
               <a:rPr lang="en-US" altLang="zh-HK" sz="800" dirty="0"/>
-              <a:t>Dagmar Hilgard did not consider hiring Ed Claiborne thoroughly</a:t>
+              <a:t>Dagmar Hilgard has a primarily finance background instead of management background</a:t>
             </a:r>
             <a:endParaRPr lang="zh-HK" altLang="en-US" sz="800" dirty="0"/>
           </a:p>
@@ -4994,10 +4985,10 @@
       </p:sp>
       <p:sp>
         <p:nvSpPr>
-          <p:cNvPr id="118" name="Rectangle: Rounded Corners 117">
-            <a:extLst>
-              <a:ext uri="{FF2B5EF4-FFF2-40B4-BE49-F238E27FC236}">
-                <a16:creationId xmlns:a16="http://schemas.microsoft.com/office/drawing/2014/main" id="{5775E6F8-A610-FDB8-6F1F-DF52722F0918}"/>
+          <p:cNvPr id="121" name="Rectangle: Rounded Corners 120">
+            <a:extLst>
+              <a:ext uri="{FF2B5EF4-FFF2-40B4-BE49-F238E27FC236}">
+                <a16:creationId xmlns:a16="http://schemas.microsoft.com/office/drawing/2014/main" id="{747AF637-D9C9-9E87-D3E7-A53600FB6F2A}"/>
               </a:ext>
             </a:extLst>
           </p:cNvPr>
@@ -5006,8 +4997,8 @@
         </p:nvSpPr>
         <p:spPr>
           <a:xfrm>
-            <a:off x="7440990" y="2894841"/>
-            <a:ext cx="1101885" cy="389904"/>
+            <a:off x="4800420" y="4994038"/>
+            <a:ext cx="1399911" cy="447210"/>
           </a:xfrm>
           <a:prstGeom prst="roundRect">
             <a:avLst/>
@@ -5034,7 +5025,7 @@
             <a:pPr algn="ctr"/>
             <a:r>
               <a:rPr lang="en-US" altLang="zh-HK" sz="800" dirty="0"/>
-              <a:t>The company chain of command is lax</a:t>
+              <a:t>Ed Claiborne requires assistance to adapt to the company culture</a:t>
             </a:r>
             <a:endParaRPr lang="zh-HK" altLang="en-US" sz="800" dirty="0"/>
           </a:p>
@@ -5042,10 +5033,10 @@
       </p:sp>
       <p:sp>
         <p:nvSpPr>
-          <p:cNvPr id="119" name="Rectangle: Rounded Corners 118">
-            <a:extLst>
-              <a:ext uri="{FF2B5EF4-FFF2-40B4-BE49-F238E27FC236}">
-                <a16:creationId xmlns:a16="http://schemas.microsoft.com/office/drawing/2014/main" id="{8CD2C558-5EF9-515D-DBB9-BB21E0DC386D}"/>
+          <p:cNvPr id="122" name="Rectangle: Rounded Corners 121">
+            <a:extLst>
+              <a:ext uri="{FF2B5EF4-FFF2-40B4-BE49-F238E27FC236}">
+                <a16:creationId xmlns:a16="http://schemas.microsoft.com/office/drawing/2014/main" id="{1CCCF22A-D21C-54C2-A375-2CB89BB3B23F}"/>
               </a:ext>
             </a:extLst>
           </p:cNvPr>
@@ -5054,8 +5045,8 @@
         </p:nvSpPr>
         <p:spPr>
           <a:xfrm>
-            <a:off x="7511745" y="3351438"/>
-            <a:ext cx="1207107" cy="491534"/>
+            <a:off x="4885045" y="5947910"/>
+            <a:ext cx="1352704" cy="346649"/>
           </a:xfrm>
           <a:prstGeom prst="roundRect">
             <a:avLst/>
@@ -5082,7 +5073,7 @@
             <a:pPr algn="ctr"/>
             <a:r>
               <a:rPr lang="en-US" altLang="zh-HK" sz="800" dirty="0"/>
-              <a:t>Ed Claiborne had been working for a firm with a strict chain of command</a:t>
+              <a:t>Insufficient assistance for Ed Claiborne</a:t>
             </a:r>
             <a:endParaRPr lang="zh-HK" altLang="en-US" sz="800" dirty="0"/>
           </a:p>
@@ -5090,10 +5081,10 @@
       </p:sp>
       <p:sp>
         <p:nvSpPr>
-          <p:cNvPr id="120" name="Rectangle: Rounded Corners 119">
-            <a:extLst>
-              <a:ext uri="{FF2B5EF4-FFF2-40B4-BE49-F238E27FC236}">
-                <a16:creationId xmlns:a16="http://schemas.microsoft.com/office/drawing/2014/main" id="{41E5EA84-36E1-4ABF-F9E5-064621B3D65C}"/>
+          <p:cNvPr id="123" name="Rectangle: Rounded Corners 122">
+            <a:extLst>
+              <a:ext uri="{FF2B5EF4-FFF2-40B4-BE49-F238E27FC236}">
+                <a16:creationId xmlns:a16="http://schemas.microsoft.com/office/drawing/2014/main" id="{B9F176C0-BBDC-15C5-089B-D716EEF20D34}"/>
               </a:ext>
             </a:extLst>
           </p:cNvPr>
@@ -5102,8 +5093,8 @@
         </p:nvSpPr>
         <p:spPr>
           <a:xfrm>
-            <a:off x="7445085" y="4081807"/>
-            <a:ext cx="1427247" cy="563318"/>
+            <a:off x="7049148" y="5095854"/>
+            <a:ext cx="1263299" cy="307777"/>
           </a:xfrm>
           <a:prstGeom prst="roundRect">
             <a:avLst/>
@@ -5130,7 +5121,7 @@
             <a:pPr algn="ctr"/>
             <a:r>
               <a:rPr lang="en-US" altLang="zh-HK" sz="800" dirty="0"/>
-              <a:t>Dagmar Hilgard has a primarily finance background instead of management background</a:t>
+              <a:t>The company culture is decentralization</a:t>
             </a:r>
             <a:endParaRPr lang="zh-HK" altLang="en-US" sz="800" dirty="0"/>
           </a:p>
@@ -5138,10 +5129,10 @@
       </p:sp>
       <p:sp>
         <p:nvSpPr>
-          <p:cNvPr id="121" name="Rectangle: Rounded Corners 120">
-            <a:extLst>
-              <a:ext uri="{FF2B5EF4-FFF2-40B4-BE49-F238E27FC236}">
-                <a16:creationId xmlns:a16="http://schemas.microsoft.com/office/drawing/2014/main" id="{747AF637-D9C9-9E87-D3E7-A53600FB6F2A}"/>
+          <p:cNvPr id="124" name="Rectangle: Rounded Corners 123">
+            <a:extLst>
+              <a:ext uri="{FF2B5EF4-FFF2-40B4-BE49-F238E27FC236}">
+                <a16:creationId xmlns:a16="http://schemas.microsoft.com/office/drawing/2014/main" id="{D03E1812-BF46-F9E0-6B32-5D1C4B711886}"/>
               </a:ext>
             </a:extLst>
           </p:cNvPr>
@@ -5150,8 +5141,8 @@
         </p:nvSpPr>
         <p:spPr>
           <a:xfrm>
-            <a:off x="4800420" y="4994038"/>
-            <a:ext cx="1399911" cy="447210"/>
+            <a:off x="7037112" y="5521862"/>
+            <a:ext cx="1207107" cy="491534"/>
           </a:xfrm>
           <a:prstGeom prst="roundRect">
             <a:avLst/>
@@ -5178,7 +5169,7 @@
             <a:pPr algn="ctr"/>
             <a:r>
               <a:rPr lang="en-US" altLang="zh-HK" sz="800" dirty="0"/>
-              <a:t>Ed Claiborne requires assistance to adapt to the company culture</a:t>
+              <a:t>Ed Claiborne had been working for a hierarchical firm</a:t>
             </a:r>
             <a:endParaRPr lang="zh-HK" altLang="en-US" sz="800" dirty="0"/>
           </a:p>
@@ -5186,10 +5177,10 @@
       </p:sp>
       <p:sp>
         <p:nvSpPr>
-          <p:cNvPr id="122" name="Rectangle: Rounded Corners 121">
-            <a:extLst>
-              <a:ext uri="{FF2B5EF4-FFF2-40B4-BE49-F238E27FC236}">
-                <a16:creationId xmlns:a16="http://schemas.microsoft.com/office/drawing/2014/main" id="{1CCCF22A-D21C-54C2-A375-2CB89BB3B23F}"/>
+          <p:cNvPr id="125" name="Rectangle: Rounded Corners 124">
+            <a:extLst>
+              <a:ext uri="{FF2B5EF4-FFF2-40B4-BE49-F238E27FC236}">
+                <a16:creationId xmlns:a16="http://schemas.microsoft.com/office/drawing/2014/main" id="{E9E8902A-9BF4-FC1F-EA8D-0126E0E883E3}"/>
               </a:ext>
             </a:extLst>
           </p:cNvPr>
@@ -5198,8 +5189,8 @@
         </p:nvSpPr>
         <p:spPr>
           <a:xfrm>
-            <a:off x="4885045" y="5947910"/>
-            <a:ext cx="1352704" cy="346649"/>
+            <a:off x="6917318" y="6179413"/>
+            <a:ext cx="1625557" cy="270356"/>
           </a:xfrm>
           <a:prstGeom prst="roundRect">
             <a:avLst/>
@@ -5226,18 +5217,663 @@
             <a:pPr algn="ctr"/>
             <a:r>
               <a:rPr lang="en-US" altLang="zh-HK" sz="800" dirty="0"/>
-              <a:t>Insufficient assistance for Ed Claiborne</a:t>
+              <a:t>Dagmar Hilgard trusts Ed Claiborne too much</a:t>
             </a:r>
             <a:endParaRPr lang="zh-HK" altLang="en-US" sz="800" dirty="0"/>
           </a:p>
         </p:txBody>
       </p:sp>
-      <p:sp>
-        <p:nvSpPr>
-          <p:cNvPr id="123" name="Rectangle: Rounded Corners 122">
-            <a:extLst>
-              <a:ext uri="{FF2B5EF4-FFF2-40B4-BE49-F238E27FC236}">
-                <a16:creationId xmlns:a16="http://schemas.microsoft.com/office/drawing/2014/main" id="{B9F176C0-BBDC-15C5-089B-D716EEF20D34}"/>
+      <p:cxnSp>
+        <p:nvCxnSpPr>
+          <p:cNvPr id="129" name="Connector: Elbow 128">
+            <a:extLst>
+              <a:ext uri="{FF2B5EF4-FFF2-40B4-BE49-F238E27FC236}">
+                <a16:creationId xmlns:a16="http://schemas.microsoft.com/office/drawing/2014/main" id="{3329717A-8BF1-9012-6C4A-15935F9F0ECD}"/>
+              </a:ext>
+            </a:extLst>
+          </p:cNvPr>
+          <p:cNvCxnSpPr>
+            <a:stCxn id="104" idx="1"/>
+            <a:endCxn id="102" idx="3"/>
+          </p:cNvCxnSpPr>
+          <p:nvPr/>
+        </p:nvCxnSpPr>
+        <p:spPr>
+          <a:xfrm rot="10800000" flipV="1">
+            <a:off x="1132115" y="2066842"/>
+            <a:ext cx="181427" cy="6282"/>
+          </a:xfrm>
+          <a:prstGeom prst="bentConnector3">
+            <a:avLst/>
+          </a:prstGeom>
+          <a:ln>
+            <a:tailEnd type="triangle"/>
+          </a:ln>
+        </p:spPr>
+        <p:style>
+          <a:lnRef idx="2">
+            <a:schemeClr val="accent1"/>
+          </a:lnRef>
+          <a:fillRef idx="0">
+            <a:schemeClr val="accent1"/>
+          </a:fillRef>
+          <a:effectRef idx="1">
+            <a:schemeClr val="accent1"/>
+          </a:effectRef>
+          <a:fontRef idx="minor">
+            <a:schemeClr val="tx1"/>
+          </a:fontRef>
+        </p:style>
+      </p:cxnSp>
+      <p:cxnSp>
+        <p:nvCxnSpPr>
+          <p:cNvPr id="131" name="Connector: Elbow 130">
+            <a:extLst>
+              <a:ext uri="{FF2B5EF4-FFF2-40B4-BE49-F238E27FC236}">
+                <a16:creationId xmlns:a16="http://schemas.microsoft.com/office/drawing/2014/main" id="{5EF3E7A3-C34D-7591-80F6-015D1134AF09}"/>
+              </a:ext>
+            </a:extLst>
+          </p:cNvPr>
+          <p:cNvCxnSpPr>
+            <a:stCxn id="98" idx="1"/>
+            <a:endCxn id="104" idx="3"/>
+          </p:cNvCxnSpPr>
+          <p:nvPr/>
+        </p:nvCxnSpPr>
+        <p:spPr>
+          <a:xfrm rot="10800000">
+            <a:off x="2520648" y="2066843"/>
+            <a:ext cx="472050" cy="3537"/>
+          </a:xfrm>
+          <a:prstGeom prst="bentConnector3">
+            <a:avLst/>
+          </a:prstGeom>
+          <a:ln>
+            <a:tailEnd type="triangle"/>
+          </a:ln>
+        </p:spPr>
+        <p:style>
+          <a:lnRef idx="2">
+            <a:schemeClr val="accent1"/>
+          </a:lnRef>
+          <a:fillRef idx="0">
+            <a:schemeClr val="accent1"/>
+          </a:fillRef>
+          <a:effectRef idx="1">
+            <a:schemeClr val="accent1"/>
+          </a:effectRef>
+          <a:fontRef idx="minor">
+            <a:schemeClr val="tx1"/>
+          </a:fontRef>
+        </p:style>
+      </p:cxnSp>
+      <p:cxnSp>
+        <p:nvCxnSpPr>
+          <p:cNvPr id="133" name="Connector: Elbow 132">
+            <a:extLst>
+              <a:ext uri="{FF2B5EF4-FFF2-40B4-BE49-F238E27FC236}">
+                <a16:creationId xmlns:a16="http://schemas.microsoft.com/office/drawing/2014/main" id="{7F4E284B-3D83-63B7-A1CB-28166E6076AA}"/>
+              </a:ext>
+            </a:extLst>
+          </p:cNvPr>
+          <p:cNvCxnSpPr>
+            <a:stCxn id="100" idx="1"/>
+            <a:endCxn id="104" idx="3"/>
+          </p:cNvCxnSpPr>
+          <p:nvPr/>
+        </p:nvCxnSpPr>
+        <p:spPr>
+          <a:xfrm rot="10800000">
+            <a:off x="2520648" y="2066842"/>
+            <a:ext cx="422118" cy="1033956"/>
+          </a:xfrm>
+          <a:prstGeom prst="bentConnector3">
+            <a:avLst/>
+          </a:prstGeom>
+          <a:ln>
+            <a:tailEnd type="triangle"/>
+          </a:ln>
+        </p:spPr>
+        <p:style>
+          <a:lnRef idx="2">
+            <a:schemeClr val="accent1"/>
+          </a:lnRef>
+          <a:fillRef idx="0">
+            <a:schemeClr val="accent1"/>
+          </a:fillRef>
+          <a:effectRef idx="1">
+            <a:schemeClr val="accent1"/>
+          </a:effectRef>
+          <a:fontRef idx="minor">
+            <a:schemeClr val="tx1"/>
+          </a:fontRef>
+        </p:style>
+      </p:cxnSp>
+      <p:cxnSp>
+        <p:nvCxnSpPr>
+          <p:cNvPr id="135" name="Connector: Elbow 134">
+            <a:extLst>
+              <a:ext uri="{FF2B5EF4-FFF2-40B4-BE49-F238E27FC236}">
+                <a16:creationId xmlns:a16="http://schemas.microsoft.com/office/drawing/2014/main" id="{5611748B-334A-CC18-4391-072544FC9A59}"/>
+              </a:ext>
+            </a:extLst>
+          </p:cNvPr>
+          <p:cNvCxnSpPr>
+            <a:stCxn id="110" idx="1"/>
+            <a:endCxn id="104" idx="3"/>
+          </p:cNvCxnSpPr>
+          <p:nvPr/>
+        </p:nvCxnSpPr>
+        <p:spPr>
+          <a:xfrm rot="10800000">
+            <a:off x="2520648" y="2066843"/>
+            <a:ext cx="422118" cy="3128639"/>
+          </a:xfrm>
+          <a:prstGeom prst="bentConnector3">
+            <a:avLst/>
+          </a:prstGeom>
+          <a:ln>
+            <a:tailEnd type="triangle"/>
+          </a:ln>
+        </p:spPr>
+        <p:style>
+          <a:lnRef idx="2">
+            <a:schemeClr val="accent1"/>
+          </a:lnRef>
+          <a:fillRef idx="0">
+            <a:schemeClr val="accent1"/>
+          </a:fillRef>
+          <a:effectRef idx="1">
+            <a:schemeClr val="accent1"/>
+          </a:effectRef>
+          <a:fontRef idx="minor">
+            <a:schemeClr val="tx1"/>
+          </a:fontRef>
+        </p:style>
+      </p:cxnSp>
+      <p:cxnSp>
+        <p:nvCxnSpPr>
+          <p:cNvPr id="138" name="Connector: Elbow 137">
+            <a:extLst>
+              <a:ext uri="{FF2B5EF4-FFF2-40B4-BE49-F238E27FC236}">
+                <a16:creationId xmlns:a16="http://schemas.microsoft.com/office/drawing/2014/main" id="{19966F91-5C5E-0D01-9104-0B2EE4F5EE3C}"/>
+              </a:ext>
+            </a:extLst>
+          </p:cNvPr>
+          <p:cNvCxnSpPr>
+            <a:cxnSpLocks/>
+            <a:stCxn id="112" idx="1"/>
+            <a:endCxn id="98" idx="3"/>
+          </p:cNvCxnSpPr>
+          <p:nvPr/>
+        </p:nvCxnSpPr>
+        <p:spPr>
+          <a:xfrm rot="10800000" flipV="1">
+            <a:off x="3873233" y="1810465"/>
+            <a:ext cx="642456" cy="259914"/>
+          </a:xfrm>
+          <a:prstGeom prst="bentConnector3">
+            <a:avLst/>
+          </a:prstGeom>
+          <a:ln>
+            <a:tailEnd type="triangle"/>
+          </a:ln>
+        </p:spPr>
+        <p:style>
+          <a:lnRef idx="2">
+            <a:schemeClr val="accent1"/>
+          </a:lnRef>
+          <a:fillRef idx="0">
+            <a:schemeClr val="accent1"/>
+          </a:fillRef>
+          <a:effectRef idx="1">
+            <a:schemeClr val="accent1"/>
+          </a:effectRef>
+          <a:fontRef idx="minor">
+            <a:schemeClr val="tx1"/>
+          </a:fontRef>
+        </p:style>
+      </p:cxnSp>
+      <p:cxnSp>
+        <p:nvCxnSpPr>
+          <p:cNvPr id="140" name="Connector: Elbow 139">
+            <a:extLst>
+              <a:ext uri="{FF2B5EF4-FFF2-40B4-BE49-F238E27FC236}">
+                <a16:creationId xmlns:a16="http://schemas.microsoft.com/office/drawing/2014/main" id="{7C9160ED-DDD7-FF2C-F499-106A3027EA72}"/>
+              </a:ext>
+            </a:extLst>
+          </p:cNvPr>
+          <p:cNvCxnSpPr>
+            <a:cxnSpLocks/>
+            <a:stCxn id="113" idx="1"/>
+            <a:endCxn id="112" idx="3"/>
+          </p:cNvCxnSpPr>
+          <p:nvPr/>
+        </p:nvCxnSpPr>
+        <p:spPr>
+          <a:xfrm rot="10800000">
+            <a:off x="6039986" y="1810465"/>
+            <a:ext cx="1419360" cy="48864"/>
+          </a:xfrm>
+          <a:prstGeom prst="bentConnector3">
+            <a:avLst/>
+          </a:prstGeom>
+          <a:ln>
+            <a:tailEnd type="triangle"/>
+          </a:ln>
+        </p:spPr>
+        <p:style>
+          <a:lnRef idx="2">
+            <a:schemeClr val="accent1"/>
+          </a:lnRef>
+          <a:fillRef idx="0">
+            <a:schemeClr val="accent1"/>
+          </a:fillRef>
+          <a:effectRef idx="1">
+            <a:schemeClr val="accent1"/>
+          </a:effectRef>
+          <a:fontRef idx="minor">
+            <a:schemeClr val="tx1"/>
+          </a:fontRef>
+        </p:style>
+      </p:cxnSp>
+      <p:cxnSp>
+        <p:nvCxnSpPr>
+          <p:cNvPr id="142" name="Connector: Elbow 141">
+            <a:extLst>
+              <a:ext uri="{FF2B5EF4-FFF2-40B4-BE49-F238E27FC236}">
+                <a16:creationId xmlns:a16="http://schemas.microsoft.com/office/drawing/2014/main" id="{1D58469F-920B-B330-17EF-FFC2F3557DEA}"/>
+              </a:ext>
+            </a:extLst>
+          </p:cNvPr>
+          <p:cNvCxnSpPr>
+            <a:cxnSpLocks/>
+            <a:stCxn id="114" idx="1"/>
+            <a:endCxn id="112" idx="3"/>
+          </p:cNvCxnSpPr>
+          <p:nvPr/>
+        </p:nvCxnSpPr>
+        <p:spPr>
+          <a:xfrm rot="10800000">
+            <a:off x="6039987" y="1810466"/>
+            <a:ext cx="1443937" cy="474001"/>
+          </a:xfrm>
+          <a:prstGeom prst="bentConnector3">
+            <a:avLst/>
+          </a:prstGeom>
+          <a:ln>
+            <a:tailEnd type="triangle"/>
+          </a:ln>
+        </p:spPr>
+        <p:style>
+          <a:lnRef idx="2">
+            <a:schemeClr val="accent1"/>
+          </a:lnRef>
+          <a:fillRef idx="0">
+            <a:schemeClr val="accent1"/>
+          </a:fillRef>
+          <a:effectRef idx="1">
+            <a:schemeClr val="accent1"/>
+          </a:effectRef>
+          <a:fontRef idx="minor">
+            <a:schemeClr val="tx1"/>
+          </a:fontRef>
+        </p:style>
+      </p:cxnSp>
+      <p:cxnSp>
+        <p:nvCxnSpPr>
+          <p:cNvPr id="144" name="Connector: Elbow 143">
+            <a:extLst>
+              <a:ext uri="{FF2B5EF4-FFF2-40B4-BE49-F238E27FC236}">
+                <a16:creationId xmlns:a16="http://schemas.microsoft.com/office/drawing/2014/main" id="{1289AC84-C438-C87E-065A-690A772B85E5}"/>
+              </a:ext>
+            </a:extLst>
+          </p:cNvPr>
+          <p:cNvCxnSpPr>
+            <a:cxnSpLocks/>
+            <a:stCxn id="115" idx="1"/>
+            <a:endCxn id="114" idx="3"/>
+          </p:cNvCxnSpPr>
+          <p:nvPr/>
+        </p:nvCxnSpPr>
+        <p:spPr>
+          <a:xfrm rot="10800000" flipV="1">
+            <a:off x="8911170" y="2276452"/>
+            <a:ext cx="1029912" cy="8013"/>
+          </a:xfrm>
+          <a:prstGeom prst="bentConnector3">
+            <a:avLst>
+              <a:gd name="adj1" fmla="val 50000"/>
+            </a:avLst>
+          </a:prstGeom>
+          <a:ln>
+            <a:tailEnd type="triangle"/>
+          </a:ln>
+        </p:spPr>
+        <p:style>
+          <a:lnRef idx="2">
+            <a:schemeClr val="accent1"/>
+          </a:lnRef>
+          <a:fillRef idx="0">
+            <a:schemeClr val="accent1"/>
+          </a:fillRef>
+          <a:effectRef idx="1">
+            <a:schemeClr val="accent1"/>
+          </a:effectRef>
+          <a:fontRef idx="minor">
+            <a:schemeClr val="tx1"/>
+          </a:fontRef>
+        </p:style>
+      </p:cxnSp>
+      <p:cxnSp>
+        <p:nvCxnSpPr>
+          <p:cNvPr id="146" name="Connector: Elbow 145">
+            <a:extLst>
+              <a:ext uri="{FF2B5EF4-FFF2-40B4-BE49-F238E27FC236}">
+                <a16:creationId xmlns:a16="http://schemas.microsoft.com/office/drawing/2014/main" id="{E63FB35E-21A5-3F4D-3FDC-4C4E86FD53BC}"/>
+              </a:ext>
+            </a:extLst>
+          </p:cNvPr>
+          <p:cNvCxnSpPr>
+            <a:cxnSpLocks/>
+            <a:stCxn id="116" idx="1"/>
+            <a:endCxn id="100" idx="3"/>
+          </p:cNvCxnSpPr>
+          <p:nvPr/>
+        </p:nvCxnSpPr>
+        <p:spPr>
+          <a:xfrm rot="10800000" flipV="1">
+            <a:off x="4149874" y="3086020"/>
+            <a:ext cx="465041" cy="14777"/>
+          </a:xfrm>
+          <a:prstGeom prst="bentConnector3">
+            <a:avLst/>
+          </a:prstGeom>
+          <a:ln>
+            <a:tailEnd type="triangle"/>
+          </a:ln>
+        </p:spPr>
+        <p:style>
+          <a:lnRef idx="2">
+            <a:schemeClr val="accent1"/>
+          </a:lnRef>
+          <a:fillRef idx="0">
+            <a:schemeClr val="accent1"/>
+          </a:fillRef>
+          <a:effectRef idx="1">
+            <a:schemeClr val="accent1"/>
+          </a:effectRef>
+          <a:fontRef idx="minor">
+            <a:schemeClr val="tx1"/>
+          </a:fontRef>
+        </p:style>
+      </p:cxnSp>
+      <p:cxnSp>
+        <p:nvCxnSpPr>
+          <p:cNvPr id="148" name="Connector: Elbow 147">
+            <a:extLst>
+              <a:ext uri="{FF2B5EF4-FFF2-40B4-BE49-F238E27FC236}">
+                <a16:creationId xmlns:a16="http://schemas.microsoft.com/office/drawing/2014/main" id="{A836C9D3-BE43-FD51-7FA6-988737A18CC3}"/>
+              </a:ext>
+            </a:extLst>
+          </p:cNvPr>
+          <p:cNvCxnSpPr>
+            <a:cxnSpLocks/>
+            <a:stCxn id="117" idx="1"/>
+            <a:endCxn id="100" idx="3"/>
+          </p:cNvCxnSpPr>
+          <p:nvPr/>
+        </p:nvCxnSpPr>
+        <p:spPr>
+          <a:xfrm rot="10800000">
+            <a:off x="4149874" y="3100798"/>
+            <a:ext cx="465041" cy="1262240"/>
+          </a:xfrm>
+          <a:prstGeom prst="bentConnector3">
+            <a:avLst/>
+          </a:prstGeom>
+          <a:ln>
+            <a:tailEnd type="triangle"/>
+          </a:ln>
+        </p:spPr>
+        <p:style>
+          <a:lnRef idx="2">
+            <a:schemeClr val="accent1"/>
+          </a:lnRef>
+          <a:fillRef idx="0">
+            <a:schemeClr val="accent1"/>
+          </a:fillRef>
+          <a:effectRef idx="1">
+            <a:schemeClr val="accent1"/>
+          </a:effectRef>
+          <a:fontRef idx="minor">
+            <a:schemeClr val="tx1"/>
+          </a:fontRef>
+        </p:style>
+      </p:cxnSp>
+      <p:cxnSp>
+        <p:nvCxnSpPr>
+          <p:cNvPr id="150" name="Connector: Elbow 149">
+            <a:extLst>
+              <a:ext uri="{FF2B5EF4-FFF2-40B4-BE49-F238E27FC236}">
+                <a16:creationId xmlns:a16="http://schemas.microsoft.com/office/drawing/2014/main" id="{D42A1401-F79C-1679-8B70-F44AFC9D5540}"/>
+              </a:ext>
+            </a:extLst>
+          </p:cNvPr>
+          <p:cNvCxnSpPr>
+            <a:cxnSpLocks/>
+            <a:stCxn id="121" idx="1"/>
+            <a:endCxn id="110" idx="3"/>
+          </p:cNvCxnSpPr>
+          <p:nvPr/>
+        </p:nvCxnSpPr>
+        <p:spPr>
+          <a:xfrm rot="10800000">
+            <a:off x="4149874" y="5195481"/>
+            <a:ext cx="650547" cy="22162"/>
+          </a:xfrm>
+          <a:prstGeom prst="bentConnector3">
+            <a:avLst/>
+          </a:prstGeom>
+          <a:ln>
+            <a:tailEnd type="triangle"/>
+          </a:ln>
+        </p:spPr>
+        <p:style>
+          <a:lnRef idx="2">
+            <a:schemeClr val="accent1"/>
+          </a:lnRef>
+          <a:fillRef idx="0">
+            <a:schemeClr val="accent1"/>
+          </a:fillRef>
+          <a:effectRef idx="1">
+            <a:schemeClr val="accent1"/>
+          </a:effectRef>
+          <a:fontRef idx="minor">
+            <a:schemeClr val="tx1"/>
+          </a:fontRef>
+        </p:style>
+      </p:cxnSp>
+      <p:cxnSp>
+        <p:nvCxnSpPr>
+          <p:cNvPr id="152" name="Connector: Elbow 151">
+            <a:extLst>
+              <a:ext uri="{FF2B5EF4-FFF2-40B4-BE49-F238E27FC236}">
+                <a16:creationId xmlns:a16="http://schemas.microsoft.com/office/drawing/2014/main" id="{37319EFA-D5C8-EB32-13C6-000A4DA0BA01}"/>
+              </a:ext>
+            </a:extLst>
+          </p:cNvPr>
+          <p:cNvCxnSpPr>
+            <a:cxnSpLocks/>
+            <a:stCxn id="122" idx="1"/>
+            <a:endCxn id="110" idx="3"/>
+          </p:cNvCxnSpPr>
+          <p:nvPr/>
+        </p:nvCxnSpPr>
+        <p:spPr>
+          <a:xfrm rot="10800000">
+            <a:off x="4149873" y="5195481"/>
+            <a:ext cx="735172" cy="925754"/>
+          </a:xfrm>
+          <a:prstGeom prst="bentConnector3">
+            <a:avLst>
+              <a:gd name="adj1" fmla="val 50000"/>
+            </a:avLst>
+          </a:prstGeom>
+          <a:ln>
+            <a:tailEnd type="triangle"/>
+          </a:ln>
+        </p:spPr>
+        <p:style>
+          <a:lnRef idx="2">
+            <a:schemeClr val="accent1"/>
+          </a:lnRef>
+          <a:fillRef idx="0">
+            <a:schemeClr val="accent1"/>
+          </a:fillRef>
+          <a:effectRef idx="1">
+            <a:schemeClr val="accent1"/>
+          </a:effectRef>
+          <a:fontRef idx="minor">
+            <a:schemeClr val="tx1"/>
+          </a:fontRef>
+        </p:style>
+      </p:cxnSp>
+      <p:cxnSp>
+        <p:nvCxnSpPr>
+          <p:cNvPr id="154" name="Connector: Elbow 153">
+            <a:extLst>
+              <a:ext uri="{FF2B5EF4-FFF2-40B4-BE49-F238E27FC236}">
+                <a16:creationId xmlns:a16="http://schemas.microsoft.com/office/drawing/2014/main" id="{AF510A5B-579C-FA3F-1706-186F67113926}"/>
+              </a:ext>
+            </a:extLst>
+          </p:cNvPr>
+          <p:cNvCxnSpPr>
+            <a:cxnSpLocks/>
+            <a:stCxn id="123" idx="1"/>
+            <a:endCxn id="121" idx="3"/>
+          </p:cNvCxnSpPr>
+          <p:nvPr/>
+        </p:nvCxnSpPr>
+        <p:spPr>
+          <a:xfrm rot="10800000">
+            <a:off x="6200332" y="5217643"/>
+            <a:ext cx="848817" cy="32100"/>
+          </a:xfrm>
+          <a:prstGeom prst="bentConnector3">
+            <a:avLst/>
+          </a:prstGeom>
+          <a:ln>
+            <a:tailEnd type="triangle"/>
+          </a:ln>
+        </p:spPr>
+        <p:style>
+          <a:lnRef idx="2">
+            <a:schemeClr val="accent1"/>
+          </a:lnRef>
+          <a:fillRef idx="0">
+            <a:schemeClr val="accent1"/>
+          </a:fillRef>
+          <a:effectRef idx="1">
+            <a:schemeClr val="accent1"/>
+          </a:effectRef>
+          <a:fontRef idx="minor">
+            <a:schemeClr val="tx1"/>
+          </a:fontRef>
+        </p:style>
+      </p:cxnSp>
+      <p:cxnSp>
+        <p:nvCxnSpPr>
+          <p:cNvPr id="156" name="Connector: Elbow 155">
+            <a:extLst>
+              <a:ext uri="{FF2B5EF4-FFF2-40B4-BE49-F238E27FC236}">
+                <a16:creationId xmlns:a16="http://schemas.microsoft.com/office/drawing/2014/main" id="{3A83F893-E7D4-7668-D6AA-F92C23587AE4}"/>
+              </a:ext>
+            </a:extLst>
+          </p:cNvPr>
+          <p:cNvCxnSpPr>
+            <a:cxnSpLocks/>
+            <a:stCxn id="124" idx="1"/>
+            <a:endCxn id="121" idx="3"/>
+          </p:cNvCxnSpPr>
+          <p:nvPr/>
+        </p:nvCxnSpPr>
+        <p:spPr>
+          <a:xfrm rot="10800000">
+            <a:off x="6200332" y="5217643"/>
+            <a:ext cx="836781" cy="549986"/>
+          </a:xfrm>
+          <a:prstGeom prst="bentConnector3">
+            <a:avLst/>
+          </a:prstGeom>
+          <a:ln>
+            <a:tailEnd type="triangle"/>
+          </a:ln>
+        </p:spPr>
+        <p:style>
+          <a:lnRef idx="2">
+            <a:schemeClr val="accent1"/>
+          </a:lnRef>
+          <a:fillRef idx="0">
+            <a:schemeClr val="accent1"/>
+          </a:fillRef>
+          <a:effectRef idx="1">
+            <a:schemeClr val="accent1"/>
+          </a:effectRef>
+          <a:fontRef idx="minor">
+            <a:schemeClr val="tx1"/>
+          </a:fontRef>
+        </p:style>
+      </p:cxnSp>
+      <p:cxnSp>
+        <p:nvCxnSpPr>
+          <p:cNvPr id="158" name="Connector: Elbow 157">
+            <a:extLst>
+              <a:ext uri="{FF2B5EF4-FFF2-40B4-BE49-F238E27FC236}">
+                <a16:creationId xmlns:a16="http://schemas.microsoft.com/office/drawing/2014/main" id="{B84B2350-8A45-8545-FCC4-37427EEA7B05}"/>
+              </a:ext>
+            </a:extLst>
+          </p:cNvPr>
+          <p:cNvCxnSpPr>
+            <a:cxnSpLocks/>
+            <a:stCxn id="125" idx="1"/>
+            <a:endCxn id="122" idx="3"/>
+          </p:cNvCxnSpPr>
+          <p:nvPr/>
+        </p:nvCxnSpPr>
+        <p:spPr>
+          <a:xfrm rot="10800000">
+            <a:off x="6237750" y="6121235"/>
+            <a:ext cx="679569" cy="193356"/>
+          </a:xfrm>
+          <a:prstGeom prst="bentConnector3">
+            <a:avLst/>
+          </a:prstGeom>
+          <a:ln>
+            <a:tailEnd type="triangle"/>
+          </a:ln>
+        </p:spPr>
+        <p:style>
+          <a:lnRef idx="2">
+            <a:schemeClr val="accent1"/>
+          </a:lnRef>
+          <a:fillRef idx="0">
+            <a:schemeClr val="accent1"/>
+          </a:fillRef>
+          <a:effectRef idx="1">
+            <a:schemeClr val="accent1"/>
+          </a:effectRef>
+          <a:fontRef idx="minor">
+            <a:schemeClr val="tx1"/>
+          </a:fontRef>
+        </p:style>
+      </p:cxnSp>
+      <p:sp>
+        <p:nvSpPr>
+          <p:cNvPr id="292" name="Rectangle: Rounded Corners 291">
+            <a:extLst>
+              <a:ext uri="{FF2B5EF4-FFF2-40B4-BE49-F238E27FC236}">
+                <a16:creationId xmlns:a16="http://schemas.microsoft.com/office/drawing/2014/main" id="{0F5103B2-D7C3-8BCC-127C-04DC3516CC90}"/>
               </a:ext>
             </a:extLst>
           </p:cNvPr>
@@ -5246,12 +5882,15 @@
         </p:nvSpPr>
         <p:spPr>
           <a:xfrm>
-            <a:off x="7049148" y="5095854"/>
-            <a:ext cx="1263299" cy="307777"/>
+            <a:off x="3137453" y="2251294"/>
+            <a:ext cx="1128978" cy="440590"/>
           </a:xfrm>
           <a:prstGeom prst="roundRect">
             <a:avLst/>
           </a:prstGeom>
+          <a:solidFill>
+            <a:srgbClr val="FFCCFF"/>
+          </a:solidFill>
         </p:spPr>
         <p:style>
           <a:lnRef idx="2">
@@ -5274,7 +5913,7 @@
             <a:pPr algn="ctr"/>
             <a:r>
               <a:rPr lang="en-US" altLang="zh-HK" sz="800" dirty="0"/>
-              <a:t>The company culture is decentralization</a:t>
+              <a:t>The plants are busy and many have added extra shifts</a:t>
             </a:r>
             <a:endParaRPr lang="zh-HK" altLang="en-US" sz="800" dirty="0"/>
           </a:p>
@@ -5282,10 +5921,10 @@
       </p:sp>
       <p:sp>
         <p:nvSpPr>
-          <p:cNvPr id="124" name="Rectangle: Rounded Corners 123">
-            <a:extLst>
-              <a:ext uri="{FF2B5EF4-FFF2-40B4-BE49-F238E27FC236}">
-                <a16:creationId xmlns:a16="http://schemas.microsoft.com/office/drawing/2014/main" id="{D03E1812-BF46-F9E0-6B32-5D1C4B711886}"/>
+          <p:cNvPr id="293" name="Rectangle: Rounded Corners 292">
+            <a:extLst>
+              <a:ext uri="{FF2B5EF4-FFF2-40B4-BE49-F238E27FC236}">
+                <a16:creationId xmlns:a16="http://schemas.microsoft.com/office/drawing/2014/main" id="{469E3633-BA46-204C-8792-6F2904512414}"/>
               </a:ext>
             </a:extLst>
           </p:cNvPr>
@@ -5294,12 +5933,18 @@
         </p:nvSpPr>
         <p:spPr>
           <a:xfrm>
-            <a:off x="7037112" y="5521862"/>
-            <a:ext cx="1207107" cy="491534"/>
+            <a:off x="2868416" y="1351459"/>
+            <a:ext cx="1192720" cy="536680"/>
           </a:xfrm>
           <a:prstGeom prst="roundRect">
             <a:avLst/>
           </a:prstGeom>
+          <a:solidFill>
+            <a:schemeClr val="accent6">
+              <a:lumMod val="60000"/>
+              <a:lumOff val="40000"/>
+            </a:schemeClr>
+          </a:solidFill>
         </p:spPr>
         <p:style>
           <a:lnRef idx="2">
@@ -5322,7 +5967,7 @@
             <a:pPr algn="ctr"/>
             <a:r>
               <a:rPr lang="en-US" altLang="zh-HK" sz="800" dirty="0"/>
-              <a:t>Ed Claiborne had been working for a hierarchical firm</a:t>
+              <a:t>Shorten policy notification advance time to 1 week or even less</a:t>
             </a:r>
             <a:endParaRPr lang="zh-HK" altLang="en-US" sz="800" dirty="0"/>
           </a:p>
@@ -5330,10 +5975,10 @@
       </p:sp>
       <p:sp>
         <p:nvSpPr>
-          <p:cNvPr id="125" name="Rectangle: Rounded Corners 124">
-            <a:extLst>
-              <a:ext uri="{FF2B5EF4-FFF2-40B4-BE49-F238E27FC236}">
-                <a16:creationId xmlns:a16="http://schemas.microsoft.com/office/drawing/2014/main" id="{E9E8902A-9BF4-FC1F-EA8D-0126E0E883E3}"/>
+          <p:cNvPr id="159" name="Rectangle: Rounded Corners 158">
+            <a:extLst>
+              <a:ext uri="{FF2B5EF4-FFF2-40B4-BE49-F238E27FC236}">
+                <a16:creationId xmlns:a16="http://schemas.microsoft.com/office/drawing/2014/main" id="{1FCFFEBE-4162-6872-1E0F-16E288DA3755}"/>
               </a:ext>
             </a:extLst>
           </p:cNvPr>
@@ -5342,12 +5987,15 @@
         </p:nvSpPr>
         <p:spPr>
           <a:xfrm>
-            <a:off x="6917318" y="6179413"/>
-            <a:ext cx="1625557" cy="270356"/>
+            <a:off x="4332516" y="1867127"/>
+            <a:ext cx="2315251" cy="352030"/>
           </a:xfrm>
           <a:prstGeom prst="roundRect">
             <a:avLst/>
           </a:prstGeom>
+          <a:solidFill>
+            <a:srgbClr val="FFCCFF"/>
+          </a:solidFill>
         </p:spPr>
         <p:style>
           <a:lnRef idx="2">
@@ -5370,7 +6018,7 @@
             <a:pPr algn="ctr"/>
             <a:r>
               <a:rPr lang="en-US" altLang="zh-HK" sz="800" dirty="0"/>
-              <a:t>Dagmar Hilgard trusts Ed Claiborne too much</a:t>
+              <a:t>Plant executives felt that temporary external circumstances caused the target shortfalls</a:t>
             </a:r>
             <a:endParaRPr lang="zh-HK" altLang="en-US" sz="800" dirty="0"/>
           </a:p>
@@ -5378,26 +6026,29 @@
       </p:sp>
       <p:cxnSp>
         <p:nvCxnSpPr>
-          <p:cNvPr id="129" name="Connector: Elbow 128">
-            <a:extLst>
-              <a:ext uri="{FF2B5EF4-FFF2-40B4-BE49-F238E27FC236}">
-                <a16:creationId xmlns:a16="http://schemas.microsoft.com/office/drawing/2014/main" id="{3329717A-8BF1-9012-6C4A-15935F9F0ECD}"/>
+          <p:cNvPr id="163" name="Connector: Elbow 162">
+            <a:extLst>
+              <a:ext uri="{FF2B5EF4-FFF2-40B4-BE49-F238E27FC236}">
+                <a16:creationId xmlns:a16="http://schemas.microsoft.com/office/drawing/2014/main" id="{3F81EF1D-1ACF-DB02-20E1-B89642FAF4D2}"/>
               </a:ext>
             </a:extLst>
           </p:cNvPr>
           <p:cNvCxnSpPr>
-            <a:stCxn id="104" idx="1"/>
-            <a:endCxn id="102" idx="3"/>
+            <a:cxnSpLocks/>
+            <a:stCxn id="118" idx="1"/>
+            <a:endCxn id="116" idx="3"/>
           </p:cNvCxnSpPr>
           <p:nvPr/>
         </p:nvCxnSpPr>
         <p:spPr>
-          <a:xfrm rot="10800000" flipV="1">
-            <a:off x="1132115" y="2066842"/>
-            <a:ext cx="181427" cy="6282"/>
+          <a:xfrm rot="10800000">
+            <a:off x="6169338" y="3086021"/>
+            <a:ext cx="1271653" cy="3772"/>
           </a:xfrm>
           <a:prstGeom prst="bentConnector3">
-            <a:avLst/>
+            <a:avLst>
+              <a:gd name="adj1" fmla="val 50000"/>
+            </a:avLst>
           </a:prstGeom>
           <a:ln>
             <a:tailEnd type="triangle"/>
@@ -5420,26 +6071,29 @@
       </p:cxnSp>
       <p:cxnSp>
         <p:nvCxnSpPr>
-          <p:cNvPr id="131" name="Connector: Elbow 130">
-            <a:extLst>
-              <a:ext uri="{FF2B5EF4-FFF2-40B4-BE49-F238E27FC236}">
-                <a16:creationId xmlns:a16="http://schemas.microsoft.com/office/drawing/2014/main" id="{5EF3E7A3-C34D-7591-80F6-015D1134AF09}"/>
+          <p:cNvPr id="165" name="Connector: Elbow 164">
+            <a:extLst>
+              <a:ext uri="{FF2B5EF4-FFF2-40B4-BE49-F238E27FC236}">
+                <a16:creationId xmlns:a16="http://schemas.microsoft.com/office/drawing/2014/main" id="{7E9BC2D0-E3D7-AD10-E614-903CA24F311E}"/>
               </a:ext>
             </a:extLst>
           </p:cNvPr>
           <p:cNvCxnSpPr>
-            <a:stCxn id="98" idx="1"/>
-            <a:endCxn id="104" idx="3"/>
+            <a:cxnSpLocks/>
+            <a:stCxn id="119" idx="1"/>
+            <a:endCxn id="116" idx="3"/>
           </p:cNvCxnSpPr>
           <p:nvPr/>
         </p:nvCxnSpPr>
         <p:spPr>
           <a:xfrm rot="10800000">
-            <a:off x="2520648" y="2066843"/>
-            <a:ext cx="472050" cy="3537"/>
+            <a:off x="6169337" y="3086021"/>
+            <a:ext cx="1342408" cy="511184"/>
           </a:xfrm>
           <a:prstGeom prst="bentConnector3">
-            <a:avLst/>
+            <a:avLst>
+              <a:gd name="adj1" fmla="val 50000"/>
+            </a:avLst>
           </a:prstGeom>
           <a:ln>
             <a:tailEnd type="triangle"/>
@@ -5462,23 +6116,24 @@
       </p:cxnSp>
       <p:cxnSp>
         <p:nvCxnSpPr>
-          <p:cNvPr id="133" name="Connector: Elbow 132">
-            <a:extLst>
-              <a:ext uri="{FF2B5EF4-FFF2-40B4-BE49-F238E27FC236}">
-                <a16:creationId xmlns:a16="http://schemas.microsoft.com/office/drawing/2014/main" id="{7F4E284B-3D83-63B7-A1CB-28166E6076AA}"/>
+          <p:cNvPr id="167" name="Connector: Elbow 166">
+            <a:extLst>
+              <a:ext uri="{FF2B5EF4-FFF2-40B4-BE49-F238E27FC236}">
+                <a16:creationId xmlns:a16="http://schemas.microsoft.com/office/drawing/2014/main" id="{4F78C872-C971-DDEC-D67B-787F96386A63}"/>
               </a:ext>
             </a:extLst>
           </p:cNvPr>
           <p:cNvCxnSpPr>
-            <a:stCxn id="100" idx="1"/>
-            <a:endCxn id="104" idx="3"/>
+            <a:cxnSpLocks/>
+            <a:stCxn id="120" idx="1"/>
+            <a:endCxn id="117" idx="3"/>
           </p:cNvCxnSpPr>
           <p:nvPr/>
         </p:nvCxnSpPr>
         <p:spPr>
           <a:xfrm rot="10800000">
-            <a:off x="2520648" y="2066842"/>
-            <a:ext cx="422118" cy="1033956"/>
+            <a:off x="6820213" y="4363038"/>
+            <a:ext cx="624873" cy="428"/>
           </a:xfrm>
           <a:prstGeom prst="bentConnector3">
             <a:avLst/>
@@ -5502,531 +6157,12 @@
           </a:fontRef>
         </p:style>
       </p:cxnSp>
-      <p:cxnSp>
-        <p:nvCxnSpPr>
-          <p:cNvPr id="135" name="Connector: Elbow 134">
-            <a:extLst>
-              <a:ext uri="{FF2B5EF4-FFF2-40B4-BE49-F238E27FC236}">
-                <a16:creationId xmlns:a16="http://schemas.microsoft.com/office/drawing/2014/main" id="{5611748B-334A-CC18-4391-072544FC9A59}"/>
-              </a:ext>
-            </a:extLst>
-          </p:cNvPr>
-          <p:cNvCxnSpPr>
-            <a:stCxn id="110" idx="1"/>
-            <a:endCxn id="104" idx="3"/>
-          </p:cNvCxnSpPr>
-          <p:nvPr/>
-        </p:nvCxnSpPr>
-        <p:spPr>
-          <a:xfrm rot="10800000">
-            <a:off x="2520648" y="2066843"/>
-            <a:ext cx="422118" cy="3128639"/>
-          </a:xfrm>
-          <a:prstGeom prst="bentConnector3">
-            <a:avLst/>
-          </a:prstGeom>
-          <a:ln>
-            <a:tailEnd type="triangle"/>
-          </a:ln>
-        </p:spPr>
-        <p:style>
-          <a:lnRef idx="2">
-            <a:schemeClr val="accent1"/>
-          </a:lnRef>
-          <a:fillRef idx="0">
-            <a:schemeClr val="accent1"/>
-          </a:fillRef>
-          <a:effectRef idx="1">
-            <a:schemeClr val="accent1"/>
-          </a:effectRef>
-          <a:fontRef idx="minor">
-            <a:schemeClr val="tx1"/>
-          </a:fontRef>
-        </p:style>
-      </p:cxnSp>
-      <p:cxnSp>
-        <p:nvCxnSpPr>
-          <p:cNvPr id="138" name="Connector: Elbow 137">
-            <a:extLst>
-              <a:ext uri="{FF2B5EF4-FFF2-40B4-BE49-F238E27FC236}">
-                <a16:creationId xmlns:a16="http://schemas.microsoft.com/office/drawing/2014/main" id="{19966F91-5C5E-0D01-9104-0B2EE4F5EE3C}"/>
-              </a:ext>
-            </a:extLst>
-          </p:cNvPr>
-          <p:cNvCxnSpPr>
-            <a:cxnSpLocks/>
-            <a:stCxn id="112" idx="1"/>
-            <a:endCxn id="98" idx="3"/>
-          </p:cNvCxnSpPr>
-          <p:nvPr/>
-        </p:nvCxnSpPr>
-        <p:spPr>
-          <a:xfrm rot="10800000" flipV="1">
-            <a:off x="3873233" y="1810465"/>
-            <a:ext cx="642456" cy="259914"/>
-          </a:xfrm>
-          <a:prstGeom prst="bentConnector3">
-            <a:avLst/>
-          </a:prstGeom>
-          <a:ln>
-            <a:tailEnd type="triangle"/>
-          </a:ln>
-        </p:spPr>
-        <p:style>
-          <a:lnRef idx="2">
-            <a:schemeClr val="accent1"/>
-          </a:lnRef>
-          <a:fillRef idx="0">
-            <a:schemeClr val="accent1"/>
-          </a:fillRef>
-          <a:effectRef idx="1">
-            <a:schemeClr val="accent1"/>
-          </a:effectRef>
-          <a:fontRef idx="minor">
-            <a:schemeClr val="tx1"/>
-          </a:fontRef>
-        </p:style>
-      </p:cxnSp>
-      <p:cxnSp>
-        <p:nvCxnSpPr>
-          <p:cNvPr id="140" name="Connector: Elbow 139">
-            <a:extLst>
-              <a:ext uri="{FF2B5EF4-FFF2-40B4-BE49-F238E27FC236}">
-                <a16:creationId xmlns:a16="http://schemas.microsoft.com/office/drawing/2014/main" id="{7C9160ED-DDD7-FF2C-F499-106A3027EA72}"/>
-              </a:ext>
-            </a:extLst>
-          </p:cNvPr>
-          <p:cNvCxnSpPr>
-            <a:cxnSpLocks/>
-            <a:stCxn id="113" idx="1"/>
-            <a:endCxn id="112" idx="3"/>
-          </p:cNvCxnSpPr>
-          <p:nvPr/>
-        </p:nvCxnSpPr>
-        <p:spPr>
-          <a:xfrm rot="10800000">
-            <a:off x="6039986" y="1810465"/>
-            <a:ext cx="1419360" cy="48864"/>
-          </a:xfrm>
-          <a:prstGeom prst="bentConnector3">
-            <a:avLst/>
-          </a:prstGeom>
-          <a:ln>
-            <a:tailEnd type="triangle"/>
-          </a:ln>
-        </p:spPr>
-        <p:style>
-          <a:lnRef idx="2">
-            <a:schemeClr val="accent1"/>
-          </a:lnRef>
-          <a:fillRef idx="0">
-            <a:schemeClr val="accent1"/>
-          </a:fillRef>
-          <a:effectRef idx="1">
-            <a:schemeClr val="accent1"/>
-          </a:effectRef>
-          <a:fontRef idx="minor">
-            <a:schemeClr val="tx1"/>
-          </a:fontRef>
-        </p:style>
-      </p:cxnSp>
-      <p:cxnSp>
-        <p:nvCxnSpPr>
-          <p:cNvPr id="142" name="Connector: Elbow 141">
-            <a:extLst>
-              <a:ext uri="{FF2B5EF4-FFF2-40B4-BE49-F238E27FC236}">
-                <a16:creationId xmlns:a16="http://schemas.microsoft.com/office/drawing/2014/main" id="{1D58469F-920B-B330-17EF-FFC2F3557DEA}"/>
-              </a:ext>
-            </a:extLst>
-          </p:cNvPr>
-          <p:cNvCxnSpPr>
-            <a:cxnSpLocks/>
-            <a:stCxn id="114" idx="1"/>
-            <a:endCxn id="112" idx="3"/>
-          </p:cNvCxnSpPr>
-          <p:nvPr/>
-        </p:nvCxnSpPr>
-        <p:spPr>
-          <a:xfrm rot="10800000">
-            <a:off x="6039987" y="1810466"/>
-            <a:ext cx="1443937" cy="474001"/>
-          </a:xfrm>
-          <a:prstGeom prst="bentConnector3">
-            <a:avLst/>
-          </a:prstGeom>
-          <a:ln>
-            <a:tailEnd type="triangle"/>
-          </a:ln>
-        </p:spPr>
-        <p:style>
-          <a:lnRef idx="2">
-            <a:schemeClr val="accent1"/>
-          </a:lnRef>
-          <a:fillRef idx="0">
-            <a:schemeClr val="accent1"/>
-          </a:fillRef>
-          <a:effectRef idx="1">
-            <a:schemeClr val="accent1"/>
-          </a:effectRef>
-          <a:fontRef idx="minor">
-            <a:schemeClr val="tx1"/>
-          </a:fontRef>
-        </p:style>
-      </p:cxnSp>
-      <p:cxnSp>
-        <p:nvCxnSpPr>
-          <p:cNvPr id="144" name="Connector: Elbow 143">
-            <a:extLst>
-              <a:ext uri="{FF2B5EF4-FFF2-40B4-BE49-F238E27FC236}">
-                <a16:creationId xmlns:a16="http://schemas.microsoft.com/office/drawing/2014/main" id="{1289AC84-C438-C87E-065A-690A772B85E5}"/>
-              </a:ext>
-            </a:extLst>
-          </p:cNvPr>
-          <p:cNvCxnSpPr>
-            <a:cxnSpLocks/>
-            <a:stCxn id="115" idx="1"/>
-            <a:endCxn id="114" idx="3"/>
-          </p:cNvCxnSpPr>
-          <p:nvPr/>
-        </p:nvCxnSpPr>
-        <p:spPr>
-          <a:xfrm rot="10800000" flipV="1">
-            <a:off x="8911170" y="2276452"/>
-            <a:ext cx="1029912" cy="8013"/>
-          </a:xfrm>
-          <a:prstGeom prst="bentConnector3">
-            <a:avLst>
-              <a:gd name="adj1" fmla="val 50000"/>
-            </a:avLst>
-          </a:prstGeom>
-          <a:ln>
-            <a:tailEnd type="triangle"/>
-          </a:ln>
-        </p:spPr>
-        <p:style>
-          <a:lnRef idx="2">
-            <a:schemeClr val="accent1"/>
-          </a:lnRef>
-          <a:fillRef idx="0">
-            <a:schemeClr val="accent1"/>
-          </a:fillRef>
-          <a:effectRef idx="1">
-            <a:schemeClr val="accent1"/>
-          </a:effectRef>
-          <a:fontRef idx="minor">
-            <a:schemeClr val="tx1"/>
-          </a:fontRef>
-        </p:style>
-      </p:cxnSp>
-      <p:cxnSp>
-        <p:nvCxnSpPr>
-          <p:cNvPr id="146" name="Connector: Elbow 145">
-            <a:extLst>
-              <a:ext uri="{FF2B5EF4-FFF2-40B4-BE49-F238E27FC236}">
-                <a16:creationId xmlns:a16="http://schemas.microsoft.com/office/drawing/2014/main" id="{E63FB35E-21A5-3F4D-3FDC-4C4E86FD53BC}"/>
-              </a:ext>
-            </a:extLst>
-          </p:cNvPr>
-          <p:cNvCxnSpPr>
-            <a:cxnSpLocks/>
-            <a:stCxn id="116" idx="1"/>
-            <a:endCxn id="100" idx="3"/>
-          </p:cNvCxnSpPr>
-          <p:nvPr/>
-        </p:nvCxnSpPr>
-        <p:spPr>
-          <a:xfrm rot="10800000" flipV="1">
-            <a:off x="4149874" y="3086020"/>
-            <a:ext cx="465041" cy="14777"/>
-          </a:xfrm>
-          <a:prstGeom prst="bentConnector3">
-            <a:avLst/>
-          </a:prstGeom>
-          <a:ln>
-            <a:tailEnd type="triangle"/>
-          </a:ln>
-        </p:spPr>
-        <p:style>
-          <a:lnRef idx="2">
-            <a:schemeClr val="accent1"/>
-          </a:lnRef>
-          <a:fillRef idx="0">
-            <a:schemeClr val="accent1"/>
-          </a:fillRef>
-          <a:effectRef idx="1">
-            <a:schemeClr val="accent1"/>
-          </a:effectRef>
-          <a:fontRef idx="minor">
-            <a:schemeClr val="tx1"/>
-          </a:fontRef>
-        </p:style>
-      </p:cxnSp>
-      <p:cxnSp>
-        <p:nvCxnSpPr>
-          <p:cNvPr id="148" name="Connector: Elbow 147">
-            <a:extLst>
-              <a:ext uri="{FF2B5EF4-FFF2-40B4-BE49-F238E27FC236}">
-                <a16:creationId xmlns:a16="http://schemas.microsoft.com/office/drawing/2014/main" id="{A836C9D3-BE43-FD51-7FA6-988737A18CC3}"/>
-              </a:ext>
-            </a:extLst>
-          </p:cNvPr>
-          <p:cNvCxnSpPr>
-            <a:cxnSpLocks/>
-            <a:stCxn id="117" idx="1"/>
-            <a:endCxn id="100" idx="3"/>
-          </p:cNvCxnSpPr>
-          <p:nvPr/>
-        </p:nvCxnSpPr>
-        <p:spPr>
-          <a:xfrm rot="10800000">
-            <a:off x="4149874" y="3100798"/>
-            <a:ext cx="465041" cy="1262240"/>
-          </a:xfrm>
-          <a:prstGeom prst="bentConnector3">
-            <a:avLst/>
-          </a:prstGeom>
-          <a:ln>
-            <a:tailEnd type="triangle"/>
-          </a:ln>
-        </p:spPr>
-        <p:style>
-          <a:lnRef idx="2">
-            <a:schemeClr val="accent1"/>
-          </a:lnRef>
-          <a:fillRef idx="0">
-            <a:schemeClr val="accent1"/>
-          </a:fillRef>
-          <a:effectRef idx="1">
-            <a:schemeClr val="accent1"/>
-          </a:effectRef>
-          <a:fontRef idx="minor">
-            <a:schemeClr val="tx1"/>
-          </a:fontRef>
-        </p:style>
-      </p:cxnSp>
-      <p:cxnSp>
-        <p:nvCxnSpPr>
-          <p:cNvPr id="150" name="Connector: Elbow 149">
-            <a:extLst>
-              <a:ext uri="{FF2B5EF4-FFF2-40B4-BE49-F238E27FC236}">
-                <a16:creationId xmlns:a16="http://schemas.microsoft.com/office/drawing/2014/main" id="{D42A1401-F79C-1679-8B70-F44AFC9D5540}"/>
-              </a:ext>
-            </a:extLst>
-          </p:cNvPr>
-          <p:cNvCxnSpPr>
-            <a:cxnSpLocks/>
-            <a:stCxn id="121" idx="1"/>
-            <a:endCxn id="110" idx="3"/>
-          </p:cNvCxnSpPr>
-          <p:nvPr/>
-        </p:nvCxnSpPr>
-        <p:spPr>
-          <a:xfrm rot="10800000">
-            <a:off x="4149874" y="5195481"/>
-            <a:ext cx="650547" cy="22162"/>
-          </a:xfrm>
-          <a:prstGeom prst="bentConnector3">
-            <a:avLst/>
-          </a:prstGeom>
-          <a:ln>
-            <a:tailEnd type="triangle"/>
-          </a:ln>
-        </p:spPr>
-        <p:style>
-          <a:lnRef idx="2">
-            <a:schemeClr val="accent1"/>
-          </a:lnRef>
-          <a:fillRef idx="0">
-            <a:schemeClr val="accent1"/>
-          </a:fillRef>
-          <a:effectRef idx="1">
-            <a:schemeClr val="accent1"/>
-          </a:effectRef>
-          <a:fontRef idx="minor">
-            <a:schemeClr val="tx1"/>
-          </a:fontRef>
-        </p:style>
-      </p:cxnSp>
-      <p:cxnSp>
-        <p:nvCxnSpPr>
-          <p:cNvPr id="152" name="Connector: Elbow 151">
-            <a:extLst>
-              <a:ext uri="{FF2B5EF4-FFF2-40B4-BE49-F238E27FC236}">
-                <a16:creationId xmlns:a16="http://schemas.microsoft.com/office/drawing/2014/main" id="{37319EFA-D5C8-EB32-13C6-000A4DA0BA01}"/>
-              </a:ext>
-            </a:extLst>
-          </p:cNvPr>
-          <p:cNvCxnSpPr>
-            <a:cxnSpLocks/>
-            <a:stCxn id="122" idx="1"/>
-            <a:endCxn id="110" idx="3"/>
-          </p:cNvCxnSpPr>
-          <p:nvPr/>
-        </p:nvCxnSpPr>
-        <p:spPr>
-          <a:xfrm rot="10800000">
-            <a:off x="4149873" y="5195481"/>
-            <a:ext cx="735172" cy="925754"/>
-          </a:xfrm>
-          <a:prstGeom prst="bentConnector3">
-            <a:avLst>
-              <a:gd name="adj1" fmla="val 50000"/>
-            </a:avLst>
-          </a:prstGeom>
-          <a:ln>
-            <a:tailEnd type="triangle"/>
-          </a:ln>
-        </p:spPr>
-        <p:style>
-          <a:lnRef idx="2">
-            <a:schemeClr val="accent1"/>
-          </a:lnRef>
-          <a:fillRef idx="0">
-            <a:schemeClr val="accent1"/>
-          </a:fillRef>
-          <a:effectRef idx="1">
-            <a:schemeClr val="accent1"/>
-          </a:effectRef>
-          <a:fontRef idx="minor">
-            <a:schemeClr val="tx1"/>
-          </a:fontRef>
-        </p:style>
-      </p:cxnSp>
-      <p:cxnSp>
-        <p:nvCxnSpPr>
-          <p:cNvPr id="154" name="Connector: Elbow 153">
-            <a:extLst>
-              <a:ext uri="{FF2B5EF4-FFF2-40B4-BE49-F238E27FC236}">
-                <a16:creationId xmlns:a16="http://schemas.microsoft.com/office/drawing/2014/main" id="{AF510A5B-579C-FA3F-1706-186F67113926}"/>
-              </a:ext>
-            </a:extLst>
-          </p:cNvPr>
-          <p:cNvCxnSpPr>
-            <a:cxnSpLocks/>
-            <a:stCxn id="123" idx="1"/>
-            <a:endCxn id="121" idx="3"/>
-          </p:cNvCxnSpPr>
-          <p:nvPr/>
-        </p:nvCxnSpPr>
-        <p:spPr>
-          <a:xfrm rot="10800000">
-            <a:off x="6200332" y="5217643"/>
-            <a:ext cx="848817" cy="32100"/>
-          </a:xfrm>
-          <a:prstGeom prst="bentConnector3">
-            <a:avLst/>
-          </a:prstGeom>
-          <a:ln>
-            <a:tailEnd type="triangle"/>
-          </a:ln>
-        </p:spPr>
-        <p:style>
-          <a:lnRef idx="2">
-            <a:schemeClr val="accent1"/>
-          </a:lnRef>
-          <a:fillRef idx="0">
-            <a:schemeClr val="accent1"/>
-          </a:fillRef>
-          <a:effectRef idx="1">
-            <a:schemeClr val="accent1"/>
-          </a:effectRef>
-          <a:fontRef idx="minor">
-            <a:schemeClr val="tx1"/>
-          </a:fontRef>
-        </p:style>
-      </p:cxnSp>
-      <p:cxnSp>
-        <p:nvCxnSpPr>
-          <p:cNvPr id="156" name="Connector: Elbow 155">
-            <a:extLst>
-              <a:ext uri="{FF2B5EF4-FFF2-40B4-BE49-F238E27FC236}">
-                <a16:creationId xmlns:a16="http://schemas.microsoft.com/office/drawing/2014/main" id="{3A83F893-E7D4-7668-D6AA-F92C23587AE4}"/>
-              </a:ext>
-            </a:extLst>
-          </p:cNvPr>
-          <p:cNvCxnSpPr>
-            <a:cxnSpLocks/>
-            <a:stCxn id="124" idx="1"/>
-            <a:endCxn id="121" idx="3"/>
-          </p:cNvCxnSpPr>
-          <p:nvPr/>
-        </p:nvCxnSpPr>
-        <p:spPr>
-          <a:xfrm rot="10800000">
-            <a:off x="6200332" y="5217643"/>
-            <a:ext cx="836781" cy="549986"/>
-          </a:xfrm>
-          <a:prstGeom prst="bentConnector3">
-            <a:avLst/>
-          </a:prstGeom>
-          <a:ln>
-            <a:tailEnd type="triangle"/>
-          </a:ln>
-        </p:spPr>
-        <p:style>
-          <a:lnRef idx="2">
-            <a:schemeClr val="accent1"/>
-          </a:lnRef>
-          <a:fillRef idx="0">
-            <a:schemeClr val="accent1"/>
-          </a:fillRef>
-          <a:effectRef idx="1">
-            <a:schemeClr val="accent1"/>
-          </a:effectRef>
-          <a:fontRef idx="minor">
-            <a:schemeClr val="tx1"/>
-          </a:fontRef>
-        </p:style>
-      </p:cxnSp>
-      <p:cxnSp>
-        <p:nvCxnSpPr>
-          <p:cNvPr id="158" name="Connector: Elbow 157">
-            <a:extLst>
-              <a:ext uri="{FF2B5EF4-FFF2-40B4-BE49-F238E27FC236}">
-                <a16:creationId xmlns:a16="http://schemas.microsoft.com/office/drawing/2014/main" id="{B84B2350-8A45-8545-FCC4-37427EEA7B05}"/>
-              </a:ext>
-            </a:extLst>
-          </p:cNvPr>
-          <p:cNvCxnSpPr>
-            <a:cxnSpLocks/>
-            <a:stCxn id="125" idx="1"/>
-            <a:endCxn id="122" idx="3"/>
-          </p:cNvCxnSpPr>
-          <p:nvPr/>
-        </p:nvCxnSpPr>
-        <p:spPr>
-          <a:xfrm rot="10800000">
-            <a:off x="6237750" y="6121235"/>
-            <a:ext cx="679569" cy="193356"/>
-          </a:xfrm>
-          <a:prstGeom prst="bentConnector3">
-            <a:avLst/>
-          </a:prstGeom>
-          <a:ln>
-            <a:tailEnd type="triangle"/>
-          </a:ln>
-        </p:spPr>
-        <p:style>
-          <a:lnRef idx="2">
-            <a:schemeClr val="accent1"/>
-          </a:lnRef>
-          <a:fillRef idx="0">
-            <a:schemeClr val="accent1"/>
-          </a:fillRef>
-          <a:effectRef idx="1">
-            <a:schemeClr val="accent1"/>
-          </a:effectRef>
-          <a:fontRef idx="minor">
-            <a:schemeClr val="tx1"/>
-          </a:fontRef>
-        </p:style>
-      </p:cxnSp>
-      <p:sp>
-        <p:nvSpPr>
-          <p:cNvPr id="292" name="Rectangle: Rounded Corners 291">
-            <a:extLst>
-              <a:ext uri="{FF2B5EF4-FFF2-40B4-BE49-F238E27FC236}">
-                <a16:creationId xmlns:a16="http://schemas.microsoft.com/office/drawing/2014/main" id="{0F5103B2-D7C3-8BCC-127C-04DC3516CC90}"/>
+      <p:sp>
+        <p:nvSpPr>
+          <p:cNvPr id="168" name="Rectangle: Rounded Corners 167">
+            <a:extLst>
+              <a:ext uri="{FF2B5EF4-FFF2-40B4-BE49-F238E27FC236}">
+                <a16:creationId xmlns:a16="http://schemas.microsoft.com/office/drawing/2014/main" id="{210E03A3-DBA0-A90B-5844-78C1F8D08365}"/>
               </a:ext>
             </a:extLst>
           </p:cNvPr>
@@ -6035,8 +6171,8 @@
         </p:nvSpPr>
         <p:spPr>
           <a:xfrm>
-            <a:off x="3137453" y="2251294"/>
-            <a:ext cx="1128978" cy="440590"/>
+            <a:off x="4542622" y="3292770"/>
+            <a:ext cx="1838730" cy="473936"/>
           </a:xfrm>
           <a:prstGeom prst="roundRect">
             <a:avLst/>
@@ -6066,7 +6202,7 @@
             <a:pPr algn="ctr"/>
             <a:r>
               <a:rPr lang="en-US" altLang="zh-HK" sz="800" dirty="0"/>
-              <a:t>The plants are busy and many have added extra shifts</a:t>
+              <a:t>Ed Claiborne ignored Lopez Debby's advice even though Debby has 14 years of experience</a:t>
             </a:r>
             <a:endParaRPr lang="zh-HK" altLang="en-US" sz="800" dirty="0"/>
           </a:p>
@@ -6074,10 +6210,10 @@
       </p:sp>
       <p:sp>
         <p:nvSpPr>
-          <p:cNvPr id="293" name="Rectangle: Rounded Corners 292">
-            <a:extLst>
-              <a:ext uri="{FF2B5EF4-FFF2-40B4-BE49-F238E27FC236}">
-                <a16:creationId xmlns:a16="http://schemas.microsoft.com/office/drawing/2014/main" id="{469E3633-BA46-204C-8792-6F2904512414}"/>
+          <p:cNvPr id="169" name="Rectangle: Rounded Corners 168">
+            <a:extLst>
+              <a:ext uri="{FF2B5EF4-FFF2-40B4-BE49-F238E27FC236}">
+                <a16:creationId xmlns:a16="http://schemas.microsoft.com/office/drawing/2014/main" id="{EC7B571D-D683-363D-C2C4-E23B2B91AB0D}"/>
               </a:ext>
             </a:extLst>
           </p:cNvPr>
@@ -6086,17 +6222,14 @@
         </p:nvSpPr>
         <p:spPr>
           <a:xfrm>
-            <a:off x="2868416" y="1351459"/>
-            <a:ext cx="1192720" cy="536680"/>
+            <a:off x="4361836" y="4505900"/>
+            <a:ext cx="2726490" cy="347745"/>
           </a:xfrm>
           <a:prstGeom prst="roundRect">
             <a:avLst/>
           </a:prstGeom>
           <a:solidFill>
-            <a:schemeClr val="accent6">
-              <a:lumMod val="60000"/>
-              <a:lumOff val="40000"/>
-            </a:schemeClr>
+            <a:srgbClr val="FFCCFF"/>
           </a:solidFill>
         </p:spPr>
         <p:style>
@@ -6120,7 +6253,7 @@
             <a:pPr algn="ctr"/>
             <a:r>
               <a:rPr lang="en-US" altLang="zh-HK" sz="800" dirty="0"/>
-              <a:t>Shorten policy notification advance time to 1 week or even less</a:t>
+              <a:t>Dagmar Hilgard hired Ed Claiborne despite the chief financial officer, Charles Suh, expressed reservations</a:t>
             </a:r>
             <a:endParaRPr lang="zh-HK" altLang="en-US" sz="800" dirty="0"/>
           </a:p>
@@ -6128,10 +6261,10 @@
       </p:sp>
       <p:sp>
         <p:nvSpPr>
-          <p:cNvPr id="159" name="Rectangle: Rounded Corners 158">
-            <a:extLst>
-              <a:ext uri="{FF2B5EF4-FFF2-40B4-BE49-F238E27FC236}">
-                <a16:creationId xmlns:a16="http://schemas.microsoft.com/office/drawing/2014/main" id="{1FCFFEBE-4162-6872-1E0F-16E288DA3755}"/>
+          <p:cNvPr id="170" name="Rectangle: Rounded Corners 169">
+            <a:extLst>
+              <a:ext uri="{FF2B5EF4-FFF2-40B4-BE49-F238E27FC236}">
+                <a16:creationId xmlns:a16="http://schemas.microsoft.com/office/drawing/2014/main" id="{B10882CF-2DA2-C0AE-9664-B9286E50A8EA}"/>
               </a:ext>
             </a:extLst>
           </p:cNvPr>
@@ -6140,14 +6273,17 @@
         </p:nvSpPr>
         <p:spPr>
           <a:xfrm>
-            <a:off x="4332516" y="1867127"/>
-            <a:ext cx="2315251" cy="352030"/>
+            <a:off x="4622587" y="3861134"/>
+            <a:ext cx="2124331" cy="346480"/>
           </a:xfrm>
           <a:prstGeom prst="roundRect">
             <a:avLst/>
           </a:prstGeom>
           <a:solidFill>
-            <a:srgbClr val="FFCCFF"/>
+            <a:schemeClr val="accent6">
+              <a:lumMod val="60000"/>
+              <a:lumOff val="40000"/>
+            </a:schemeClr>
           </a:solidFill>
         </p:spPr>
         <p:style>
@@ -6171,151 +6307,18 @@
             <a:pPr algn="ctr"/>
             <a:r>
               <a:rPr lang="en-US" altLang="zh-HK" sz="800" dirty="0"/>
-              <a:t>Plant executives felt that temporary external circumstances caused the target shortfalls</a:t>
+              <a:t>The candidate being appointed a high-level position also requires approval from the board of directors</a:t>
             </a:r>
             <a:endParaRPr lang="zh-HK" altLang="en-US" sz="800" dirty="0"/>
           </a:p>
         </p:txBody>
       </p:sp>
-      <p:cxnSp>
-        <p:nvCxnSpPr>
-          <p:cNvPr id="163" name="Connector: Elbow 162">
-            <a:extLst>
-              <a:ext uri="{FF2B5EF4-FFF2-40B4-BE49-F238E27FC236}">
-                <a16:creationId xmlns:a16="http://schemas.microsoft.com/office/drawing/2014/main" id="{3F81EF1D-1ACF-DB02-20E1-B89642FAF4D2}"/>
-              </a:ext>
-            </a:extLst>
-          </p:cNvPr>
-          <p:cNvCxnSpPr>
-            <a:cxnSpLocks/>
-            <a:stCxn id="118" idx="1"/>
-            <a:endCxn id="116" idx="3"/>
-          </p:cNvCxnSpPr>
-          <p:nvPr/>
-        </p:nvCxnSpPr>
-        <p:spPr>
-          <a:xfrm rot="10800000">
-            <a:off x="6169338" y="3086021"/>
-            <a:ext cx="1271653" cy="3772"/>
-          </a:xfrm>
-          <a:prstGeom prst="bentConnector3">
-            <a:avLst>
-              <a:gd name="adj1" fmla="val 50000"/>
-            </a:avLst>
-          </a:prstGeom>
-          <a:ln>
-            <a:tailEnd type="triangle"/>
-          </a:ln>
-        </p:spPr>
-        <p:style>
-          <a:lnRef idx="2">
-            <a:schemeClr val="accent1"/>
-          </a:lnRef>
-          <a:fillRef idx="0">
-            <a:schemeClr val="accent1"/>
-          </a:fillRef>
-          <a:effectRef idx="1">
-            <a:schemeClr val="accent1"/>
-          </a:effectRef>
-          <a:fontRef idx="minor">
-            <a:schemeClr val="tx1"/>
-          </a:fontRef>
-        </p:style>
-      </p:cxnSp>
-      <p:cxnSp>
-        <p:nvCxnSpPr>
-          <p:cNvPr id="165" name="Connector: Elbow 164">
-            <a:extLst>
-              <a:ext uri="{FF2B5EF4-FFF2-40B4-BE49-F238E27FC236}">
-                <a16:creationId xmlns:a16="http://schemas.microsoft.com/office/drawing/2014/main" id="{7E9BC2D0-E3D7-AD10-E614-903CA24F311E}"/>
-              </a:ext>
-            </a:extLst>
-          </p:cNvPr>
-          <p:cNvCxnSpPr>
-            <a:cxnSpLocks/>
-            <a:stCxn id="119" idx="1"/>
-            <a:endCxn id="116" idx="3"/>
-          </p:cNvCxnSpPr>
-          <p:nvPr/>
-        </p:nvCxnSpPr>
-        <p:spPr>
-          <a:xfrm rot="10800000">
-            <a:off x="6169337" y="3086021"/>
-            <a:ext cx="1342408" cy="511184"/>
-          </a:xfrm>
-          <a:prstGeom prst="bentConnector3">
-            <a:avLst>
-              <a:gd name="adj1" fmla="val 50000"/>
-            </a:avLst>
-          </a:prstGeom>
-          <a:ln>
-            <a:tailEnd type="triangle"/>
-          </a:ln>
-        </p:spPr>
-        <p:style>
-          <a:lnRef idx="2">
-            <a:schemeClr val="accent1"/>
-          </a:lnRef>
-          <a:fillRef idx="0">
-            <a:schemeClr val="accent1"/>
-          </a:fillRef>
-          <a:effectRef idx="1">
-            <a:schemeClr val="accent1"/>
-          </a:effectRef>
-          <a:fontRef idx="minor">
-            <a:schemeClr val="tx1"/>
-          </a:fontRef>
-        </p:style>
-      </p:cxnSp>
-      <p:cxnSp>
-        <p:nvCxnSpPr>
-          <p:cNvPr id="167" name="Connector: Elbow 166">
-            <a:extLst>
-              <a:ext uri="{FF2B5EF4-FFF2-40B4-BE49-F238E27FC236}">
-                <a16:creationId xmlns:a16="http://schemas.microsoft.com/office/drawing/2014/main" id="{4F78C872-C971-DDEC-D67B-787F96386A63}"/>
-              </a:ext>
-            </a:extLst>
-          </p:cNvPr>
-          <p:cNvCxnSpPr>
-            <a:cxnSpLocks/>
-            <a:stCxn id="120" idx="1"/>
-            <a:endCxn id="117" idx="3"/>
-          </p:cNvCxnSpPr>
-          <p:nvPr/>
-        </p:nvCxnSpPr>
-        <p:spPr>
-          <a:xfrm rot="10800000">
-            <a:off x="6820213" y="4363038"/>
-            <a:ext cx="624873" cy="428"/>
-          </a:xfrm>
-          <a:prstGeom prst="bentConnector3">
-            <a:avLst/>
-          </a:prstGeom>
-          <a:ln>
-            <a:tailEnd type="triangle"/>
-          </a:ln>
-        </p:spPr>
-        <p:style>
-          <a:lnRef idx="2">
-            <a:schemeClr val="accent1"/>
-          </a:lnRef>
-          <a:fillRef idx="0">
-            <a:schemeClr val="accent1"/>
-          </a:fillRef>
-          <a:effectRef idx="1">
-            <a:schemeClr val="accent1"/>
-          </a:effectRef>
-          <a:fontRef idx="minor">
-            <a:schemeClr val="tx1"/>
-          </a:fontRef>
-        </p:style>
-      </p:cxnSp>
-      <p:sp>
-        <p:nvSpPr>
-          <p:cNvPr id="168" name="Rectangle: Rounded Corners 167">
-            <a:extLst>
-              <a:ext uri="{FF2B5EF4-FFF2-40B4-BE49-F238E27FC236}">
-                <a16:creationId xmlns:a16="http://schemas.microsoft.com/office/drawing/2014/main" id="{210E03A3-DBA0-A90B-5844-78C1F8D08365}"/>
+      <p:sp>
+        <p:nvSpPr>
+          <p:cNvPr id="171" name="Rectangle: Rounded Corners 170">
+            <a:extLst>
+              <a:ext uri="{FF2B5EF4-FFF2-40B4-BE49-F238E27FC236}">
+                <a16:creationId xmlns:a16="http://schemas.microsoft.com/office/drawing/2014/main" id="{3615F2D6-08CD-2978-C578-36AF2711F3A3}"/>
               </a:ext>
             </a:extLst>
           </p:cNvPr>
@@ -6324,14 +6327,17 @@
         </p:nvSpPr>
         <p:spPr>
           <a:xfrm>
-            <a:off x="4542622" y="3292770"/>
-            <a:ext cx="1838730" cy="473936"/>
+            <a:off x="4871974" y="5644359"/>
+            <a:ext cx="1406249" cy="361419"/>
           </a:xfrm>
           <a:prstGeom prst="roundRect">
             <a:avLst/>
           </a:prstGeom>
           <a:solidFill>
-            <a:srgbClr val="FFCCFF"/>
+            <a:schemeClr val="accent6">
+              <a:lumMod val="60000"/>
+              <a:lumOff val="40000"/>
+            </a:schemeClr>
           </a:solidFill>
         </p:spPr>
         <p:style>
@@ -6355,7 +6361,7 @@
             <a:pPr algn="ctr"/>
             <a:r>
               <a:rPr lang="en-US" altLang="zh-HK" sz="800" dirty="0"/>
-              <a:t>Ed Claiborne ignored Lopez Debby's advice even though Debby has 14 years of experience</a:t>
+              <a:t>Onboarding for new high-level employees</a:t>
             </a:r>
             <a:endParaRPr lang="zh-HK" altLang="en-US" sz="800" dirty="0"/>
           </a:p>
@@ -6363,10 +6369,10 @@
       </p:sp>
       <p:sp>
         <p:nvSpPr>
-          <p:cNvPr id="169" name="Rectangle: Rounded Corners 168">
-            <a:extLst>
-              <a:ext uri="{FF2B5EF4-FFF2-40B4-BE49-F238E27FC236}">
-                <a16:creationId xmlns:a16="http://schemas.microsoft.com/office/drawing/2014/main" id="{EC7B571D-D683-363D-C2C4-E23B2B91AB0D}"/>
+          <p:cNvPr id="172" name="Rectangle: Rounded Corners 171">
+            <a:extLst>
+              <a:ext uri="{FF2B5EF4-FFF2-40B4-BE49-F238E27FC236}">
+                <a16:creationId xmlns:a16="http://schemas.microsoft.com/office/drawing/2014/main" id="{AB54EA75-732C-50BC-6D89-54E5DAB1B072}"/>
               </a:ext>
             </a:extLst>
           </p:cNvPr>
@@ -6375,8 +6381,8 @@
         </p:nvSpPr>
         <p:spPr>
           <a:xfrm>
-            <a:off x="4361836" y="4505900"/>
-            <a:ext cx="2726490" cy="347745"/>
+            <a:off x="6805164" y="6455976"/>
+            <a:ext cx="2029198" cy="328056"/>
           </a:xfrm>
           <a:prstGeom prst="roundRect">
             <a:avLst/>
@@ -6406,7 +6412,7 @@
             <a:pPr algn="ctr"/>
             <a:r>
               <a:rPr lang="en-US" altLang="zh-HK" sz="800" dirty="0"/>
-              <a:t>Dagmar Hilgard hired Ed Claiborne despite the chief financial officer, Charles Suh, expressed reservations</a:t>
+              <a:t>Dagmar Hilgard did not need to know the details of policy implementation</a:t>
             </a:r>
             <a:endParaRPr lang="zh-HK" altLang="en-US" sz="800" dirty="0"/>
           </a:p>
@@ -6414,10 +6420,10 @@
       </p:sp>
       <p:sp>
         <p:nvSpPr>
-          <p:cNvPr id="170" name="Rectangle: Rounded Corners 169">
-            <a:extLst>
-              <a:ext uri="{FF2B5EF4-FFF2-40B4-BE49-F238E27FC236}">
-                <a16:creationId xmlns:a16="http://schemas.microsoft.com/office/drawing/2014/main" id="{B10882CF-2DA2-C0AE-9664-B9286E50A8EA}"/>
+          <p:cNvPr id="173" name="Rectangle: Rounded Corners 172">
+            <a:extLst>
+              <a:ext uri="{FF2B5EF4-FFF2-40B4-BE49-F238E27FC236}">
+                <a16:creationId xmlns:a16="http://schemas.microsoft.com/office/drawing/2014/main" id="{25A11DA1-A225-E22E-DE5C-B9A37F34F6B7}"/>
               </a:ext>
             </a:extLst>
           </p:cNvPr>
@@ -6426,17 +6432,14 @@
         </p:nvSpPr>
         <p:spPr>
           <a:xfrm>
-            <a:off x="4622587" y="3861134"/>
-            <a:ext cx="2124331" cy="346480"/>
+            <a:off x="4962231" y="6259109"/>
+            <a:ext cx="1207106" cy="491533"/>
           </a:xfrm>
           <a:prstGeom prst="roundRect">
             <a:avLst/>
           </a:prstGeom>
           <a:solidFill>
-            <a:schemeClr val="accent6">
-              <a:lumMod val="60000"/>
-              <a:lumOff val="40000"/>
-            </a:schemeClr>
+            <a:srgbClr val="FFCCFF"/>
           </a:solidFill>
         </p:spPr>
         <p:style>
@@ -6460,7 +6463,7 @@
             <a:pPr algn="ctr"/>
             <a:r>
               <a:rPr lang="en-US" altLang="zh-HK" sz="800" dirty="0"/>
-              <a:t>The candidate being appointed a high-level position also requires approval from the board of directors</a:t>
+              <a:t>Ed Claiborne was already assigned work on his first day</a:t>
             </a:r>
             <a:endParaRPr lang="zh-HK" altLang="en-US" sz="800" dirty="0"/>
           </a:p>
@@ -6468,10 +6471,334 @@
       </p:sp>
       <p:sp>
         <p:nvSpPr>
-          <p:cNvPr id="171" name="Rectangle: Rounded Corners 170">
-            <a:extLst>
-              <a:ext uri="{FF2B5EF4-FFF2-40B4-BE49-F238E27FC236}">
-                <a16:creationId xmlns:a16="http://schemas.microsoft.com/office/drawing/2014/main" id="{3615F2D6-08CD-2978-C578-36AF2711F3A3}"/>
+          <p:cNvPr id="174" name="TextBox 173">
+            <a:extLst>
+              <a:ext uri="{FF2B5EF4-FFF2-40B4-BE49-F238E27FC236}">
+                <a16:creationId xmlns:a16="http://schemas.microsoft.com/office/drawing/2014/main" id="{F4FFB1B9-24A7-C660-F836-F64A6E2456AB}"/>
+              </a:ext>
+            </a:extLst>
+          </p:cNvPr>
+          <p:cNvSpPr txBox="1"/>
+          <p:nvPr/>
+        </p:nvSpPr>
+        <p:spPr>
+          <a:xfrm>
+            <a:off x="2024690" y="2295227"/>
+            <a:ext cx="1112762" cy="307777"/>
+          </a:xfrm>
+          <a:prstGeom prst="rect">
+            <a:avLst/>
+          </a:prstGeom>
+          <a:noFill/>
+        </p:spPr>
+        <p:txBody>
+          <a:bodyPr wrap="square" rtlCol="0">
+            <a:spAutoFit/>
+          </a:bodyPr>
+          <a:lstStyle/>
+          <a:p>
+            <a:r>
+              <a:rPr lang="en-US" altLang="zh-HK" sz="1400" dirty="0"/>
+              <a:t>7S: Strategy</a:t>
+            </a:r>
+            <a:endParaRPr lang="zh-HK" altLang="en-US" sz="1400" dirty="0"/>
+          </a:p>
+        </p:txBody>
+      </p:sp>
+      <p:sp>
+        <p:nvSpPr>
+          <p:cNvPr id="175" name="TextBox 174">
+            <a:extLst>
+              <a:ext uri="{FF2B5EF4-FFF2-40B4-BE49-F238E27FC236}">
+                <a16:creationId xmlns:a16="http://schemas.microsoft.com/office/drawing/2014/main" id="{8E2856EF-BB31-8FA6-7E4D-CFAE8C384ECE}"/>
+              </a:ext>
+            </a:extLst>
+          </p:cNvPr>
+          <p:cNvSpPr txBox="1"/>
+          <p:nvPr/>
+        </p:nvSpPr>
+        <p:spPr>
+          <a:xfrm>
+            <a:off x="2119884" y="3116354"/>
+            <a:ext cx="1112762" cy="307777"/>
+          </a:xfrm>
+          <a:prstGeom prst="rect">
+            <a:avLst/>
+          </a:prstGeom>
+          <a:noFill/>
+        </p:spPr>
+        <p:txBody>
+          <a:bodyPr wrap="square" rtlCol="0">
+            <a:spAutoFit/>
+          </a:bodyPr>
+          <a:lstStyle/>
+          <a:p>
+            <a:r>
+              <a:rPr lang="en-US" altLang="zh-HK" sz="1400" dirty="0"/>
+              <a:t>7S: Staff</a:t>
+            </a:r>
+            <a:endParaRPr lang="zh-HK" altLang="en-US" sz="1400" dirty="0"/>
+          </a:p>
+        </p:txBody>
+      </p:sp>
+      <p:sp>
+        <p:nvSpPr>
+          <p:cNvPr id="176" name="TextBox 175">
+            <a:extLst>
+              <a:ext uri="{FF2B5EF4-FFF2-40B4-BE49-F238E27FC236}">
+                <a16:creationId xmlns:a16="http://schemas.microsoft.com/office/drawing/2014/main" id="{C5A80876-00F1-CC96-D29D-B8CCD11D9EA0}"/>
+              </a:ext>
+            </a:extLst>
+          </p:cNvPr>
+          <p:cNvSpPr txBox="1"/>
+          <p:nvPr/>
+        </p:nvSpPr>
+        <p:spPr>
+          <a:xfrm>
+            <a:off x="2075642" y="5171277"/>
+            <a:ext cx="1112762" cy="307777"/>
+          </a:xfrm>
+          <a:prstGeom prst="rect">
+            <a:avLst/>
+          </a:prstGeom>
+          <a:noFill/>
+        </p:spPr>
+        <p:txBody>
+          <a:bodyPr wrap="square" rtlCol="0">
+            <a:spAutoFit/>
+          </a:bodyPr>
+          <a:lstStyle/>
+          <a:p>
+            <a:r>
+              <a:rPr lang="en-US" altLang="zh-HK" sz="1400" dirty="0"/>
+              <a:t>7S: Skills</a:t>
+            </a:r>
+            <a:endParaRPr lang="zh-HK" altLang="en-US" sz="1400" dirty="0"/>
+          </a:p>
+        </p:txBody>
+      </p:sp>
+      <p:sp>
+        <p:nvSpPr>
+          <p:cNvPr id="177" name="TextBox 176">
+            <a:extLst>
+              <a:ext uri="{FF2B5EF4-FFF2-40B4-BE49-F238E27FC236}">
+                <a16:creationId xmlns:a16="http://schemas.microsoft.com/office/drawing/2014/main" id="{72339393-9F91-3B91-06D4-F2597F772FB2}"/>
+              </a:ext>
+            </a:extLst>
+          </p:cNvPr>
+          <p:cNvSpPr txBox="1"/>
+          <p:nvPr/>
+        </p:nvSpPr>
+        <p:spPr>
+          <a:xfrm>
+            <a:off x="6161003" y="1504061"/>
+            <a:ext cx="574746" cy="307777"/>
+          </a:xfrm>
+          <a:prstGeom prst="rect">
+            <a:avLst/>
+          </a:prstGeom>
+          <a:noFill/>
+        </p:spPr>
+        <p:txBody>
+          <a:bodyPr wrap="square" rtlCol="0">
+            <a:spAutoFit/>
+          </a:bodyPr>
+          <a:lstStyle/>
+          <a:p>
+            <a:r>
+              <a:rPr lang="en-US" altLang="zh-HK" sz="1400" dirty="0"/>
+              <a:t>AND</a:t>
+            </a:r>
+            <a:endParaRPr lang="zh-HK" altLang="en-US" sz="1400" dirty="0"/>
+          </a:p>
+        </p:txBody>
+      </p:sp>
+      <p:sp>
+        <p:nvSpPr>
+          <p:cNvPr id="178" name="TextBox 177">
+            <a:extLst>
+              <a:ext uri="{FF2B5EF4-FFF2-40B4-BE49-F238E27FC236}">
+                <a16:creationId xmlns:a16="http://schemas.microsoft.com/office/drawing/2014/main" id="{48ADB190-025B-499B-CE6B-38A454210AF9}"/>
+              </a:ext>
+            </a:extLst>
+          </p:cNvPr>
+          <p:cNvSpPr txBox="1"/>
+          <p:nvPr/>
+        </p:nvSpPr>
+        <p:spPr>
+          <a:xfrm>
+            <a:off x="2456741" y="1748257"/>
+            <a:ext cx="574746" cy="307777"/>
+          </a:xfrm>
+          <a:prstGeom prst="rect">
+            <a:avLst/>
+          </a:prstGeom>
+          <a:noFill/>
+        </p:spPr>
+        <p:txBody>
+          <a:bodyPr wrap="square" rtlCol="0">
+            <a:spAutoFit/>
+          </a:bodyPr>
+          <a:lstStyle/>
+          <a:p>
+            <a:r>
+              <a:rPr lang="en-US" altLang="zh-HK" sz="1400" dirty="0"/>
+              <a:t>OR</a:t>
+            </a:r>
+            <a:endParaRPr lang="zh-HK" altLang="en-US" sz="1400" dirty="0"/>
+          </a:p>
+        </p:txBody>
+      </p:sp>
+      <p:sp>
+        <p:nvSpPr>
+          <p:cNvPr id="179" name="TextBox 178">
+            <a:extLst>
+              <a:ext uri="{FF2B5EF4-FFF2-40B4-BE49-F238E27FC236}">
+                <a16:creationId xmlns:a16="http://schemas.microsoft.com/office/drawing/2014/main" id="{67AD908A-FF4C-E097-5C9D-A2BBCAD5223F}"/>
+              </a:ext>
+            </a:extLst>
+          </p:cNvPr>
+          <p:cNvSpPr txBox="1"/>
+          <p:nvPr/>
+        </p:nvSpPr>
+        <p:spPr>
+          <a:xfrm>
+            <a:off x="6200331" y="2731136"/>
+            <a:ext cx="574746" cy="307777"/>
+          </a:xfrm>
+          <a:prstGeom prst="rect">
+            <a:avLst/>
+          </a:prstGeom>
+          <a:noFill/>
+        </p:spPr>
+        <p:txBody>
+          <a:bodyPr wrap="square" rtlCol="0">
+            <a:spAutoFit/>
+          </a:bodyPr>
+          <a:lstStyle/>
+          <a:p>
+            <a:r>
+              <a:rPr lang="en-US" altLang="zh-HK" sz="1400" dirty="0"/>
+              <a:t>AND</a:t>
+            </a:r>
+            <a:endParaRPr lang="zh-HK" altLang="en-US" sz="1400" dirty="0"/>
+          </a:p>
+        </p:txBody>
+      </p:sp>
+      <p:sp>
+        <p:nvSpPr>
+          <p:cNvPr id="180" name="TextBox 179">
+            <a:extLst>
+              <a:ext uri="{FF2B5EF4-FFF2-40B4-BE49-F238E27FC236}">
+                <a16:creationId xmlns:a16="http://schemas.microsoft.com/office/drawing/2014/main" id="{18EF3EAA-C9C7-46F6-1869-E26F9D304CD6}"/>
+              </a:ext>
+            </a:extLst>
+          </p:cNvPr>
+          <p:cNvSpPr txBox="1"/>
+          <p:nvPr/>
+        </p:nvSpPr>
+        <p:spPr>
+          <a:xfrm>
+            <a:off x="4115526" y="2714757"/>
+            <a:ext cx="574746" cy="307777"/>
+          </a:xfrm>
+          <a:prstGeom prst="rect">
+            <a:avLst/>
+          </a:prstGeom>
+          <a:noFill/>
+        </p:spPr>
+        <p:txBody>
+          <a:bodyPr wrap="square" rtlCol="0">
+            <a:spAutoFit/>
+          </a:bodyPr>
+          <a:lstStyle/>
+          <a:p>
+            <a:r>
+              <a:rPr lang="en-US" altLang="zh-HK" sz="1400" dirty="0"/>
+              <a:t>AND</a:t>
+            </a:r>
+            <a:endParaRPr lang="zh-HK" altLang="en-US" sz="1400" dirty="0"/>
+          </a:p>
+        </p:txBody>
+      </p:sp>
+      <p:sp>
+        <p:nvSpPr>
+          <p:cNvPr id="183" name="TextBox 182">
+            <a:extLst>
+              <a:ext uri="{FF2B5EF4-FFF2-40B4-BE49-F238E27FC236}">
+                <a16:creationId xmlns:a16="http://schemas.microsoft.com/office/drawing/2014/main" id="{45D20551-EEFF-008C-E228-5C74DF318FB0}"/>
+              </a:ext>
+            </a:extLst>
+          </p:cNvPr>
+          <p:cNvSpPr txBox="1"/>
+          <p:nvPr/>
+        </p:nvSpPr>
+        <p:spPr>
+          <a:xfrm>
+            <a:off x="6300127" y="4870224"/>
+            <a:ext cx="574746" cy="307777"/>
+          </a:xfrm>
+          <a:prstGeom prst="rect">
+            <a:avLst/>
+          </a:prstGeom>
+          <a:noFill/>
+        </p:spPr>
+        <p:txBody>
+          <a:bodyPr wrap="square" rtlCol="0">
+            <a:spAutoFit/>
+          </a:bodyPr>
+          <a:lstStyle/>
+          <a:p>
+            <a:r>
+              <a:rPr lang="en-US" altLang="zh-HK" sz="1400" dirty="0"/>
+              <a:t>AND</a:t>
+            </a:r>
+            <a:endParaRPr lang="zh-HK" altLang="en-US" sz="1400" dirty="0"/>
+          </a:p>
+        </p:txBody>
+      </p:sp>
+      <p:sp>
+        <p:nvSpPr>
+          <p:cNvPr id="185" name="TextBox 184">
+            <a:extLst>
+              <a:ext uri="{FF2B5EF4-FFF2-40B4-BE49-F238E27FC236}">
+                <a16:creationId xmlns:a16="http://schemas.microsoft.com/office/drawing/2014/main" id="{3B880DDB-F2DF-22A8-B0A5-B98A64F44B47}"/>
+              </a:ext>
+            </a:extLst>
+          </p:cNvPr>
+          <p:cNvSpPr txBox="1"/>
+          <p:nvPr/>
+        </p:nvSpPr>
+        <p:spPr>
+          <a:xfrm>
+            <a:off x="4125878" y="4870224"/>
+            <a:ext cx="574746" cy="307777"/>
+          </a:xfrm>
+          <a:prstGeom prst="rect">
+            <a:avLst/>
+          </a:prstGeom>
+          <a:noFill/>
+        </p:spPr>
+        <p:txBody>
+          <a:bodyPr wrap="square" rtlCol="0">
+            <a:spAutoFit/>
+          </a:bodyPr>
+          <a:lstStyle/>
+          <a:p>
+            <a:r>
+              <a:rPr lang="en-US" altLang="zh-HK" sz="1400" dirty="0"/>
+              <a:t>AND</a:t>
+            </a:r>
+            <a:endParaRPr lang="zh-HK" altLang="en-US" sz="1400" dirty="0"/>
+          </a:p>
+        </p:txBody>
+      </p:sp>
+      <p:sp>
+        <p:nvSpPr>
+          <p:cNvPr id="3" name="Rectangle: Rounded Corners 2">
+            <a:extLst>
+              <a:ext uri="{FF2B5EF4-FFF2-40B4-BE49-F238E27FC236}">
+                <a16:creationId xmlns:a16="http://schemas.microsoft.com/office/drawing/2014/main" id="{DE442E0D-CE20-0AD7-F318-0FCCF03CAA7E}"/>
               </a:ext>
             </a:extLst>
           </p:cNvPr>
@@ -6480,18 +6807,12 @@
         </p:nvSpPr>
         <p:spPr>
           <a:xfrm>
-            <a:off x="4871974" y="5644359"/>
-            <a:ext cx="1406249" cy="361419"/>
+            <a:off x="10990648" y="655385"/>
+            <a:ext cx="937911" cy="329926"/>
           </a:xfrm>
           <a:prstGeom prst="roundRect">
             <a:avLst/>
           </a:prstGeom>
-          <a:solidFill>
-            <a:schemeClr val="accent6">
-              <a:lumMod val="60000"/>
-              <a:lumOff val="40000"/>
-            </a:schemeClr>
-          </a:solidFill>
         </p:spPr>
         <p:style>
           <a:lnRef idx="2">
@@ -6513,19 +6834,19 @@
           <a:p>
             <a:pPr algn="ctr"/>
             <a:r>
-              <a:rPr lang="en-US" altLang="zh-HK" sz="800" dirty="0"/>
-              <a:t>Onboarding for new high-level employees</a:t>
-            </a:r>
-            <a:endParaRPr lang="zh-HK" altLang="en-US" sz="800" dirty="0"/>
-          </a:p>
-        </p:txBody>
-      </p:sp>
-      <p:sp>
-        <p:nvSpPr>
-          <p:cNvPr id="172" name="Rectangle: Rounded Corners 171">
-            <a:extLst>
-              <a:ext uri="{FF2B5EF4-FFF2-40B4-BE49-F238E27FC236}">
-                <a16:creationId xmlns:a16="http://schemas.microsoft.com/office/drawing/2014/main" id="{AB54EA75-732C-50BC-6D89-54E5DAB1B072}"/>
+              <a:rPr lang="en-US" altLang="zh-HK" sz="1400" dirty="0"/>
+              <a:t>Element</a:t>
+            </a:r>
+            <a:endParaRPr lang="zh-HK" altLang="en-US" sz="1400" dirty="0"/>
+          </a:p>
+        </p:txBody>
+      </p:sp>
+      <p:sp>
+        <p:nvSpPr>
+          <p:cNvPr id="4" name="Rectangle: Rounded Corners 3">
+            <a:extLst>
+              <a:ext uri="{FF2B5EF4-FFF2-40B4-BE49-F238E27FC236}">
+                <a16:creationId xmlns:a16="http://schemas.microsoft.com/office/drawing/2014/main" id="{72BDDE57-BA92-8F8D-E3DF-186CF3E5570B}"/>
               </a:ext>
             </a:extLst>
           </p:cNvPr>
@@ -6534,14 +6855,17 @@
         </p:nvSpPr>
         <p:spPr>
           <a:xfrm>
-            <a:off x="6805164" y="6455976"/>
-            <a:ext cx="2029198" cy="328056"/>
+            <a:off x="10990766" y="344231"/>
+            <a:ext cx="881137" cy="361419"/>
           </a:xfrm>
           <a:prstGeom prst="roundRect">
             <a:avLst/>
           </a:prstGeom>
           <a:solidFill>
-            <a:srgbClr val="FFCCFF"/>
+            <a:schemeClr val="accent6">
+              <a:lumMod val="60000"/>
+              <a:lumOff val="40000"/>
+            </a:schemeClr>
           </a:solidFill>
         </p:spPr>
         <p:style>
@@ -6564,19 +6888,19 @@
           <a:p>
             <a:pPr algn="ctr"/>
             <a:r>
-              <a:rPr lang="en-US" altLang="zh-HK" sz="800" dirty="0"/>
-              <a:t>Dagmar Hilgard did not need to know the details of policy implementation</a:t>
-            </a:r>
-            <a:endParaRPr lang="zh-HK" altLang="en-US" sz="800" dirty="0"/>
-          </a:p>
-        </p:txBody>
-      </p:sp>
-      <p:sp>
-        <p:nvSpPr>
-          <p:cNvPr id="173" name="Rectangle: Rounded Corners 172">
-            <a:extLst>
-              <a:ext uri="{FF2B5EF4-FFF2-40B4-BE49-F238E27FC236}">
-                <a16:creationId xmlns:a16="http://schemas.microsoft.com/office/drawing/2014/main" id="{25A11DA1-A225-E22E-DE5C-B9A37F34F6B7}"/>
+              <a:rPr lang="en-US" altLang="zh-HK" sz="1400" dirty="0"/>
+              <a:t>Solution</a:t>
+            </a:r>
+            <a:endParaRPr lang="zh-HK" altLang="en-US" sz="1400" dirty="0"/>
+          </a:p>
+        </p:txBody>
+      </p:sp>
+      <p:sp>
+        <p:nvSpPr>
+          <p:cNvPr id="5" name="Rectangle: Rounded Corners 4">
+            <a:extLst>
+              <a:ext uri="{FF2B5EF4-FFF2-40B4-BE49-F238E27FC236}">
+                <a16:creationId xmlns:a16="http://schemas.microsoft.com/office/drawing/2014/main" id="{5D68D801-7867-9272-B71A-9D43B9B0FCD9}"/>
               </a:ext>
             </a:extLst>
           </p:cNvPr>
@@ -6585,8 +6909,8 @@
         </p:nvSpPr>
         <p:spPr>
           <a:xfrm>
-            <a:off x="4962231" y="6259109"/>
-            <a:ext cx="1207106" cy="491533"/>
+            <a:off x="10962342" y="937685"/>
+            <a:ext cx="966218" cy="339980"/>
           </a:xfrm>
           <a:prstGeom prst="roundRect">
             <a:avLst/>
@@ -6615,332 +6939,8 @@
           <a:p>
             <a:pPr algn="ctr"/>
             <a:r>
-              <a:rPr lang="en-US" altLang="zh-HK" sz="800" dirty="0"/>
-              <a:t>Ed Claiborne was already assigned work on his first day</a:t>
-            </a:r>
-            <a:endParaRPr lang="zh-HK" altLang="en-US" sz="800" dirty="0"/>
-          </a:p>
-        </p:txBody>
-      </p:sp>
-      <p:sp>
-        <p:nvSpPr>
-          <p:cNvPr id="174" name="TextBox 173">
-            <a:extLst>
-              <a:ext uri="{FF2B5EF4-FFF2-40B4-BE49-F238E27FC236}">
-                <a16:creationId xmlns:a16="http://schemas.microsoft.com/office/drawing/2014/main" id="{F4FFB1B9-24A7-C660-F836-F64A6E2456AB}"/>
-              </a:ext>
-            </a:extLst>
-          </p:cNvPr>
-          <p:cNvSpPr txBox="1"/>
-          <p:nvPr/>
-        </p:nvSpPr>
-        <p:spPr>
-          <a:xfrm>
-            <a:off x="2024690" y="2295227"/>
-            <a:ext cx="1112762" cy="307777"/>
-          </a:xfrm>
-          <a:prstGeom prst="rect">
-            <a:avLst/>
-          </a:prstGeom>
-          <a:noFill/>
-        </p:spPr>
-        <p:txBody>
-          <a:bodyPr wrap="square" rtlCol="0">
-            <a:spAutoFit/>
-          </a:bodyPr>
-          <a:lstStyle/>
-          <a:p>
-            <a:r>
               <a:rPr lang="en-US" altLang="zh-HK" sz="1400" dirty="0"/>
-              <a:t>7S: Strategy</a:t>
-            </a:r>
-            <a:endParaRPr lang="zh-HK" altLang="en-US" sz="1400" dirty="0"/>
-          </a:p>
-        </p:txBody>
-      </p:sp>
-      <p:sp>
-        <p:nvSpPr>
-          <p:cNvPr id="175" name="TextBox 174">
-            <a:extLst>
-              <a:ext uri="{FF2B5EF4-FFF2-40B4-BE49-F238E27FC236}">
-                <a16:creationId xmlns:a16="http://schemas.microsoft.com/office/drawing/2014/main" id="{8E2856EF-BB31-8FA6-7E4D-CFAE8C384ECE}"/>
-              </a:ext>
-            </a:extLst>
-          </p:cNvPr>
-          <p:cNvSpPr txBox="1"/>
-          <p:nvPr/>
-        </p:nvSpPr>
-        <p:spPr>
-          <a:xfrm>
-            <a:off x="2119884" y="3116354"/>
-            <a:ext cx="1112762" cy="307777"/>
-          </a:xfrm>
-          <a:prstGeom prst="rect">
-            <a:avLst/>
-          </a:prstGeom>
-          <a:noFill/>
-        </p:spPr>
-        <p:txBody>
-          <a:bodyPr wrap="square" rtlCol="0">
-            <a:spAutoFit/>
-          </a:bodyPr>
-          <a:lstStyle/>
-          <a:p>
-            <a:r>
-              <a:rPr lang="en-US" altLang="zh-HK" sz="1400" dirty="0"/>
-              <a:t>7S: Staff</a:t>
-            </a:r>
-            <a:endParaRPr lang="zh-HK" altLang="en-US" sz="1400" dirty="0"/>
-          </a:p>
-        </p:txBody>
-      </p:sp>
-      <p:sp>
-        <p:nvSpPr>
-          <p:cNvPr id="176" name="TextBox 175">
-            <a:extLst>
-              <a:ext uri="{FF2B5EF4-FFF2-40B4-BE49-F238E27FC236}">
-                <a16:creationId xmlns:a16="http://schemas.microsoft.com/office/drawing/2014/main" id="{C5A80876-00F1-CC96-D29D-B8CCD11D9EA0}"/>
-              </a:ext>
-            </a:extLst>
-          </p:cNvPr>
-          <p:cNvSpPr txBox="1"/>
-          <p:nvPr/>
-        </p:nvSpPr>
-        <p:spPr>
-          <a:xfrm>
-            <a:off x="2075642" y="5171277"/>
-            <a:ext cx="1112762" cy="307777"/>
-          </a:xfrm>
-          <a:prstGeom prst="rect">
-            <a:avLst/>
-          </a:prstGeom>
-          <a:noFill/>
-        </p:spPr>
-        <p:txBody>
-          <a:bodyPr wrap="square" rtlCol="0">
-            <a:spAutoFit/>
-          </a:bodyPr>
-          <a:lstStyle/>
-          <a:p>
-            <a:r>
-              <a:rPr lang="en-US" altLang="zh-HK" sz="1400" dirty="0"/>
-              <a:t>7S: Skills</a:t>
-            </a:r>
-            <a:endParaRPr lang="zh-HK" altLang="en-US" sz="1400" dirty="0"/>
-          </a:p>
-        </p:txBody>
-      </p:sp>
-      <p:sp>
-        <p:nvSpPr>
-          <p:cNvPr id="177" name="TextBox 176">
-            <a:extLst>
-              <a:ext uri="{FF2B5EF4-FFF2-40B4-BE49-F238E27FC236}">
-                <a16:creationId xmlns:a16="http://schemas.microsoft.com/office/drawing/2014/main" id="{72339393-9F91-3B91-06D4-F2597F772FB2}"/>
-              </a:ext>
-            </a:extLst>
-          </p:cNvPr>
-          <p:cNvSpPr txBox="1"/>
-          <p:nvPr/>
-        </p:nvSpPr>
-        <p:spPr>
-          <a:xfrm>
-            <a:off x="6161003" y="1504061"/>
-            <a:ext cx="574746" cy="307777"/>
-          </a:xfrm>
-          <a:prstGeom prst="rect">
-            <a:avLst/>
-          </a:prstGeom>
-          <a:noFill/>
-        </p:spPr>
-        <p:txBody>
-          <a:bodyPr wrap="square" rtlCol="0">
-            <a:spAutoFit/>
-          </a:bodyPr>
-          <a:lstStyle/>
-          <a:p>
-            <a:r>
-              <a:rPr lang="en-US" altLang="zh-HK" sz="1400" dirty="0"/>
-              <a:t>AND</a:t>
-            </a:r>
-            <a:endParaRPr lang="zh-HK" altLang="en-US" sz="1400" dirty="0"/>
-          </a:p>
-        </p:txBody>
-      </p:sp>
-      <p:sp>
-        <p:nvSpPr>
-          <p:cNvPr id="178" name="TextBox 177">
-            <a:extLst>
-              <a:ext uri="{FF2B5EF4-FFF2-40B4-BE49-F238E27FC236}">
-                <a16:creationId xmlns:a16="http://schemas.microsoft.com/office/drawing/2014/main" id="{48ADB190-025B-499B-CE6B-38A454210AF9}"/>
-              </a:ext>
-            </a:extLst>
-          </p:cNvPr>
-          <p:cNvSpPr txBox="1"/>
-          <p:nvPr/>
-        </p:nvSpPr>
-        <p:spPr>
-          <a:xfrm>
-            <a:off x="2456741" y="1748257"/>
-            <a:ext cx="574746" cy="307777"/>
-          </a:xfrm>
-          <a:prstGeom prst="rect">
-            <a:avLst/>
-          </a:prstGeom>
-          <a:noFill/>
-        </p:spPr>
-        <p:txBody>
-          <a:bodyPr wrap="square" rtlCol="0">
-            <a:spAutoFit/>
-          </a:bodyPr>
-          <a:lstStyle/>
-          <a:p>
-            <a:r>
-              <a:rPr lang="en-US" altLang="zh-HK" sz="1400" dirty="0"/>
-              <a:t>OR</a:t>
-            </a:r>
-            <a:endParaRPr lang="zh-HK" altLang="en-US" sz="1400" dirty="0"/>
-          </a:p>
-        </p:txBody>
-      </p:sp>
-      <p:sp>
-        <p:nvSpPr>
-          <p:cNvPr id="179" name="TextBox 178">
-            <a:extLst>
-              <a:ext uri="{FF2B5EF4-FFF2-40B4-BE49-F238E27FC236}">
-                <a16:creationId xmlns:a16="http://schemas.microsoft.com/office/drawing/2014/main" id="{67AD908A-FF4C-E097-5C9D-A2BBCAD5223F}"/>
-              </a:ext>
-            </a:extLst>
-          </p:cNvPr>
-          <p:cNvSpPr txBox="1"/>
-          <p:nvPr/>
-        </p:nvSpPr>
-        <p:spPr>
-          <a:xfrm>
-            <a:off x="6200331" y="2731136"/>
-            <a:ext cx="574746" cy="307777"/>
-          </a:xfrm>
-          <a:prstGeom prst="rect">
-            <a:avLst/>
-          </a:prstGeom>
-          <a:noFill/>
-        </p:spPr>
-        <p:txBody>
-          <a:bodyPr wrap="square" rtlCol="0">
-            <a:spAutoFit/>
-          </a:bodyPr>
-          <a:lstStyle/>
-          <a:p>
-            <a:r>
-              <a:rPr lang="en-US" altLang="zh-HK" sz="1400" dirty="0"/>
-              <a:t>AND</a:t>
-            </a:r>
-            <a:endParaRPr lang="zh-HK" altLang="en-US" sz="1400" dirty="0"/>
-          </a:p>
-        </p:txBody>
-      </p:sp>
-      <p:sp>
-        <p:nvSpPr>
-          <p:cNvPr id="180" name="TextBox 179">
-            <a:extLst>
-              <a:ext uri="{FF2B5EF4-FFF2-40B4-BE49-F238E27FC236}">
-                <a16:creationId xmlns:a16="http://schemas.microsoft.com/office/drawing/2014/main" id="{18EF3EAA-C9C7-46F6-1869-E26F9D304CD6}"/>
-              </a:ext>
-            </a:extLst>
-          </p:cNvPr>
-          <p:cNvSpPr txBox="1"/>
-          <p:nvPr/>
-        </p:nvSpPr>
-        <p:spPr>
-          <a:xfrm>
-            <a:off x="4115526" y="2714757"/>
-            <a:ext cx="574746" cy="307777"/>
-          </a:xfrm>
-          <a:prstGeom prst="rect">
-            <a:avLst/>
-          </a:prstGeom>
-          <a:noFill/>
-        </p:spPr>
-        <p:txBody>
-          <a:bodyPr wrap="square" rtlCol="0">
-            <a:spAutoFit/>
-          </a:bodyPr>
-          <a:lstStyle/>
-          <a:p>
-            <a:r>
-              <a:rPr lang="en-US" altLang="zh-HK" sz="1400" dirty="0"/>
-              <a:t>AND</a:t>
-            </a:r>
-            <a:endParaRPr lang="zh-HK" altLang="en-US" sz="1400" dirty="0"/>
-          </a:p>
-        </p:txBody>
-      </p:sp>
-      <p:sp>
-        <p:nvSpPr>
-          <p:cNvPr id="183" name="TextBox 182">
-            <a:extLst>
-              <a:ext uri="{FF2B5EF4-FFF2-40B4-BE49-F238E27FC236}">
-                <a16:creationId xmlns:a16="http://schemas.microsoft.com/office/drawing/2014/main" id="{45D20551-EEFF-008C-E228-5C74DF318FB0}"/>
-              </a:ext>
-            </a:extLst>
-          </p:cNvPr>
-          <p:cNvSpPr txBox="1"/>
-          <p:nvPr/>
-        </p:nvSpPr>
-        <p:spPr>
-          <a:xfrm>
-            <a:off x="6300127" y="4870224"/>
-            <a:ext cx="574746" cy="307777"/>
-          </a:xfrm>
-          <a:prstGeom prst="rect">
-            <a:avLst/>
-          </a:prstGeom>
-          <a:noFill/>
-        </p:spPr>
-        <p:txBody>
-          <a:bodyPr wrap="square" rtlCol="0">
-            <a:spAutoFit/>
-          </a:bodyPr>
-          <a:lstStyle/>
-          <a:p>
-            <a:r>
-              <a:rPr lang="en-US" altLang="zh-HK" sz="1400" dirty="0"/>
-              <a:t>AND</a:t>
-            </a:r>
-            <a:endParaRPr lang="zh-HK" altLang="en-US" sz="1400" dirty="0"/>
-          </a:p>
-        </p:txBody>
-      </p:sp>
-      <p:sp>
-        <p:nvSpPr>
-          <p:cNvPr id="185" name="TextBox 184">
-            <a:extLst>
-              <a:ext uri="{FF2B5EF4-FFF2-40B4-BE49-F238E27FC236}">
-                <a16:creationId xmlns:a16="http://schemas.microsoft.com/office/drawing/2014/main" id="{3B880DDB-F2DF-22A8-B0A5-B98A64F44B47}"/>
-              </a:ext>
-            </a:extLst>
-          </p:cNvPr>
-          <p:cNvSpPr txBox="1"/>
-          <p:nvPr/>
-        </p:nvSpPr>
-        <p:spPr>
-          <a:xfrm>
-            <a:off x="4125878" y="4870224"/>
-            <a:ext cx="574746" cy="307777"/>
-          </a:xfrm>
-          <a:prstGeom prst="rect">
-            <a:avLst/>
-          </a:prstGeom>
-          <a:noFill/>
-        </p:spPr>
-        <p:txBody>
-          <a:bodyPr wrap="square" rtlCol="0">
-            <a:spAutoFit/>
-          </a:bodyPr>
-          <a:lstStyle/>
-          <a:p>
-            <a:r>
-              <a:rPr lang="en-US" altLang="zh-HK" sz="1400" dirty="0"/>
-              <a:t>AND</a:t>
+              <a:t>Evidence</a:t>
             </a:r>
             <a:endParaRPr lang="zh-HK" altLang="en-US" sz="1400" dirty="0"/>
           </a:p>
@@ -7418,8 +7418,8 @@
         </p:nvSpPr>
         <p:spPr>
           <a:xfrm>
-            <a:off x="10990649" y="655385"/>
-            <a:ext cx="860600" cy="329926"/>
+            <a:off x="10990648" y="655385"/>
+            <a:ext cx="937911" cy="329926"/>
           </a:xfrm>
           <a:prstGeom prst="roundRect">
             <a:avLst/>
@@ -10837,7 +10837,7 @@
       </p:grpSpPr>
       <p:sp useBgFill="1">
         <p:nvSpPr>
-          <p:cNvPr id="52" name="Rectangle 51">
+          <p:cNvPr id="74" name="Rectangle 73">
             <a:extLst>
               <a:ext uri="{FF2B5EF4-FFF2-40B4-BE49-F238E27FC236}">
                 <a16:creationId xmlns:a16="http://schemas.microsoft.com/office/drawing/2014/main" id="{A8384FB5-9ADC-4DDC-881B-597D56F5B15D}"/>
@@ -10913,7 +10913,7 @@
       </p:sp>
       <p:sp>
         <p:nvSpPr>
-          <p:cNvPr id="53" name="Rectangle 52">
+          <p:cNvPr id="76" name="Rectangle 75">
             <a:extLst>
               <a:ext uri="{FF2B5EF4-FFF2-40B4-BE49-F238E27FC236}">
                 <a16:creationId xmlns:a16="http://schemas.microsoft.com/office/drawing/2014/main" id="{1199E1B1-A8C0-4FE8-A5A8-1CB41D69F857}"/>
@@ -10988,7 +10988,7 @@
       </p:sp>
       <p:sp>
         <p:nvSpPr>
-          <p:cNvPr id="67" name="Rectangle 66">
+          <p:cNvPr id="78" name="Rectangle 77">
             <a:extLst>
               <a:ext uri="{FF2B5EF4-FFF2-40B4-BE49-F238E27FC236}">
                 <a16:creationId xmlns:a16="http://schemas.microsoft.com/office/drawing/2014/main" id="{84A8DE83-DE75-4B41-9DB4-A7EC0B0DEC0B}"/>
@@ -11065,7 +11065,7 @@
       </p:sp>
       <p:sp>
         <p:nvSpPr>
-          <p:cNvPr id="69" name="Rectangle 68">
+          <p:cNvPr id="80" name="Rectangle 79">
             <a:extLst>
               <a:ext uri="{FF2B5EF4-FFF2-40B4-BE49-F238E27FC236}">
                 <a16:creationId xmlns:a16="http://schemas.microsoft.com/office/drawing/2014/main" id="{A7009A0A-BEF5-4EAC-AF15-E4F9F002E239}"/>
@@ -11180,6 +11180,51 @@
           </a:p>
         </p:txBody>
       </p:sp>
+      <p:sp>
+        <p:nvSpPr>
+          <p:cNvPr id="4" name="Content Placeholder 4">
+            <a:extLst>
+              <a:ext uri="{FF2B5EF4-FFF2-40B4-BE49-F238E27FC236}">
+                <a16:creationId xmlns:a16="http://schemas.microsoft.com/office/drawing/2014/main" id="{C6062CBC-0B7B-00DE-CE85-B404EF4B6121}"/>
+              </a:ext>
+            </a:extLst>
+          </p:cNvPr>
+          <p:cNvSpPr>
+            <a:spLocks noGrp="1"/>
+          </p:cNvSpPr>
+          <p:nvPr>
+            <p:ph idx="1"/>
+          </p:nvPr>
+        </p:nvSpPr>
+        <p:spPr>
+          <a:xfrm>
+            <a:off x="8572499" y="390832"/>
+            <a:ext cx="3233585" cy="873612"/>
+          </a:xfrm>
+        </p:spPr>
+        <p:txBody>
+          <a:bodyPr vert="horz" lIns="91440" tIns="45720" rIns="91440" bIns="45720" rtlCol="0" anchor="ctr">
+            <a:normAutofit fontScale="85000" lnSpcReduction="20000"/>
+          </a:bodyPr>
+          <a:lstStyle/>
+          <a:p>
+            <a:pPr marL="0" indent="0">
+              <a:buNone/>
+            </a:pPr>
+            <a:r>
+              <a:rPr lang="en-US" altLang="zh-HK" sz="2000" kern="1200" dirty="0">
+                <a:solidFill>
+                  <a:srgbClr val="FFFFFF"/>
+                </a:solidFill>
+                <a:latin typeface="+mn-lt"/>
+                <a:ea typeface="+mn-ea"/>
+                <a:cs typeface="+mn-cs"/>
+              </a:rPr>
+              <a:t>For capability, a red dot means “broken”, a yellow rot means “slightly broken”, and a green dot means “OK”.</a:t>
+            </a:r>
+          </a:p>
+        </p:txBody>
+      </p:sp>
       <p:graphicFrame>
         <p:nvGraphicFramePr>
           <p:cNvPr id="3" name="Table 2">
@@ -11195,14 +11240,14 @@
           <p:nvPr>
             <p:extLst>
               <p:ext uri="{D42A27DB-BD31-4B8C-83A1-F6EECF244321}">
-                <p14:modId xmlns:p14="http://schemas.microsoft.com/office/powerpoint/2010/main" val="56160260"/>
+                <p14:modId xmlns:p14="http://schemas.microsoft.com/office/powerpoint/2010/main" val="507091681"/>
               </p:ext>
             </p:extLst>
           </p:nvPr>
         </p:nvGraphicFramePr>
         <p:xfrm>
-          <a:off x="432225" y="2252451"/>
-          <a:ext cx="11327550" cy="3879847"/>
+          <a:off x="432225" y="2156164"/>
+          <a:ext cx="11327550" cy="4072422"/>
         </p:xfrm>
         <a:graphic>
           <a:graphicData uri="http://schemas.openxmlformats.org/drawingml/2006/table">
@@ -11211,21 +11256,21 @@
                 <a:tableStyleId>{5C22544A-7EE6-4342-B048-85BDC9FD1C3A}</a:tableStyleId>
               </a:tblPr>
               <a:tblGrid>
-                <a:gridCol w="2528584">
+                <a:gridCol w="1989964">
                   <a:extLst>
                     <a:ext uri="{9D8B030D-6E8A-4147-A177-3AD203B41FA5}">
                       <a16:colId xmlns:a16="http://schemas.microsoft.com/office/drawing/2014/main" val="230623537"/>
                     </a:ext>
                   </a:extLst>
                 </a:gridCol>
-                <a:gridCol w="1338811">
+                <a:gridCol w="1407240">
                   <a:extLst>
                     <a:ext uri="{9D8B030D-6E8A-4147-A177-3AD203B41FA5}">
                       <a16:colId xmlns:a16="http://schemas.microsoft.com/office/drawing/2014/main" val="3012309499"/>
                     </a:ext>
                   </a:extLst>
                 </a:gridCol>
-                <a:gridCol w="7460155">
+                <a:gridCol w="7930346">
                   <a:extLst>
                     <a:ext uri="{9D8B030D-6E8A-4147-A177-3AD203B41FA5}">
                       <a16:colId xmlns:a16="http://schemas.microsoft.com/office/drawing/2014/main" val="4183110492"/>
@@ -11233,7 +11278,7 @@
                   </a:extLst>
                 </a:gridCol>
               </a:tblGrid>
-              <a:tr h="261764">
+              <a:tr h="274776">
                 <a:tc>
                   <a:txBody>
                     <a:bodyPr/>
@@ -11248,18 +11293,18 @@
                         </a:spcAft>
                       </a:pPr>
                       <a:r>
-                        <a:rPr lang="en-US" sz="1300" b="0" u="none" strike="noStrike">
+                        <a:rPr lang="en-US" sz="1400" b="0" u="none" strike="noStrike">
                           <a:effectLst/>
                         </a:rPr>
                         <a:t>7S dimension</a:t>
                       </a:r>
-                      <a:endParaRPr lang="en-US" altLang="zh-HK" sz="1300" b="0" i="0" u="none" strike="noStrike">
+                      <a:endParaRPr lang="en-US" altLang="zh-HK" sz="1400" b="0" i="0" u="none" strike="noStrike">
                         <a:effectLst/>
                         <a:latin typeface="Arial" panose="020B0604020202020204" pitchFamily="34" charset="0"/>
                       </a:endParaRPr>
                     </a:p>
                   </a:txBody>
-                  <a:tcPr marL="26719" marR="26719" marT="13359" marB="13359" anchor="ctr"/>
+                  <a:tcPr marL="28085" marR="28085" marT="14042" marB="14042" anchor="ctr"/>
                 </a:tc>
                 <a:tc>
                   <a:txBody>
@@ -11275,18 +11320,18 @@
                         </a:spcAft>
                       </a:pPr>
                       <a:r>
-                        <a:rPr lang="en-US" sz="1300" b="0" u="none" strike="noStrike" dirty="0">
+                        <a:rPr lang="en-US" sz="1400" b="0" u="none" strike="noStrike">
                           <a:effectLst/>
                         </a:rPr>
                         <a:t>Capability</a:t>
                       </a:r>
-                      <a:endParaRPr lang="en-US" altLang="zh-HK" sz="1300" b="0" i="0" u="none" strike="noStrike" dirty="0">
+                      <a:endParaRPr lang="en-US" altLang="zh-HK" sz="1400" b="0" i="0" u="none" strike="noStrike">
                         <a:effectLst/>
                         <a:latin typeface="Arial" panose="020B0604020202020204" pitchFamily="34" charset="0"/>
                       </a:endParaRPr>
                     </a:p>
                   </a:txBody>
-                  <a:tcPr marL="26719" marR="26719" marT="13359" marB="13359" anchor="ctr"/>
+                  <a:tcPr marL="28085" marR="28085" marT="14042" marB="14042" anchor="ctr"/>
                 </a:tc>
                 <a:tc>
                   <a:txBody>
@@ -11302,18 +11347,18 @@
                         </a:spcAft>
                       </a:pPr>
                       <a:r>
-                        <a:rPr lang="en-US" sz="1300" b="0" u="none" strike="noStrike">
+                        <a:rPr lang="en-US" sz="1400" b="0" u="none" strike="noStrike">
                           <a:effectLst/>
                         </a:rPr>
                         <a:t>Rationale</a:t>
                       </a:r>
-                      <a:endParaRPr lang="en-US" altLang="zh-HK" sz="1300" b="0" i="0" u="none" strike="noStrike">
+                      <a:endParaRPr lang="en-US" altLang="zh-HK" sz="1400" b="0" i="0" u="none" strike="noStrike">
                         <a:effectLst/>
                         <a:latin typeface="Arial" panose="020B0604020202020204" pitchFamily="34" charset="0"/>
                       </a:endParaRPr>
                     </a:p>
                   </a:txBody>
-                  <a:tcPr marL="26719" marR="26719" marT="13359" marB="13359" anchor="ctr"/>
+                  <a:tcPr marL="28085" marR="28085" marT="14042" marB="14042" anchor="ctr"/>
                 </a:tc>
                 <a:extLst>
                   <a:ext uri="{0D108BD9-81ED-4DB2-BD59-A6C34878D82A}">
@@ -11321,7 +11366,7 @@
                   </a:ext>
                 </a:extLst>
               </a:tr>
-              <a:tr h="460179">
+              <a:tr h="483022">
                 <a:tc>
                   <a:txBody>
                     <a:bodyPr/>
@@ -11336,18 +11381,18 @@
                         </a:spcAft>
                       </a:pPr>
                       <a:r>
-                        <a:rPr lang="en-US" sz="1300" b="0" u="none" strike="noStrike">
+                        <a:rPr lang="en-US" sz="1400" b="0" u="none" strike="noStrike">
                           <a:effectLst/>
                         </a:rPr>
                         <a:t>Strategy</a:t>
                       </a:r>
-                      <a:endParaRPr lang="en-US" altLang="zh-HK" sz="1300" b="0" i="0" u="none" strike="noStrike">
+                      <a:endParaRPr lang="en-US" altLang="zh-HK" sz="1400" b="0" i="0" u="none" strike="noStrike">
                         <a:effectLst/>
                         <a:latin typeface="Arial" panose="020B0604020202020204" pitchFamily="34" charset="0"/>
                       </a:endParaRPr>
                     </a:p>
                   </a:txBody>
-                  <a:tcPr marL="26719" marR="26719" marT="13359" marB="13359" anchor="ctr"/>
+                  <a:tcPr marL="28085" marR="28085" marT="14042" marB="14042" anchor="ctr"/>
                 </a:tc>
                 <a:tc>
                   <a:txBody>
@@ -11363,7 +11408,7 @@
                         </a:spcAft>
                       </a:pPr>
                       <a:r>
-                        <a:rPr lang="zh-HK" altLang="en-US" sz="1300" b="0" u="none" strike="noStrike" dirty="0">
+                        <a:rPr lang="zh-HK" altLang="en-US" sz="1400" b="0" u="none" strike="noStrike">
                           <a:solidFill>
                             <a:srgbClr val="FFD700"/>
                           </a:solidFill>
@@ -11371,7 +11416,7 @@
                         </a:rPr>
                         <a:t>●</a:t>
                       </a:r>
-                      <a:endParaRPr lang="zh-HK" altLang="en-US" sz="1300" b="0" i="0" u="none" strike="noStrike" dirty="0">
+                      <a:endParaRPr lang="zh-HK" altLang="en-US" sz="1400" b="0" i="0" u="none" strike="noStrike">
                         <a:solidFill>
                           <a:srgbClr val="FFD700"/>
                         </a:solidFill>
@@ -11380,7 +11425,7 @@
                       </a:endParaRPr>
                     </a:p>
                   </a:txBody>
-                  <a:tcPr marL="26719" marR="26719" marT="13359" marB="13359" anchor="ctr"/>
+                  <a:tcPr marL="28085" marR="28085" marT="14042" marB="14042" anchor="ctr"/>
                 </a:tc>
                 <a:tc>
                   <a:txBody>
@@ -11396,18 +11441,18 @@
                         </a:spcAft>
                       </a:pPr>
                       <a:r>
-                        <a:rPr lang="en-US" sz="1300" b="0" u="none" strike="noStrike">
+                        <a:rPr lang="en-US" sz="1400" b="0" u="none" strike="noStrike">
                           <a:effectLst/>
                         </a:rPr>
                         <a:t>The company management can consider strategies other than cost reduction, such as reducing the proportion of fixed-cost contracts.</a:t>
                       </a:r>
-                      <a:endParaRPr lang="en-US" altLang="zh-HK" sz="1300" b="0" i="0" u="none" strike="noStrike">
+                      <a:endParaRPr lang="en-US" altLang="zh-HK" sz="1400" b="0" i="0" u="none" strike="noStrike">
                         <a:effectLst/>
                         <a:latin typeface="Arial" panose="020B0604020202020204" pitchFamily="34" charset="0"/>
                       </a:endParaRPr>
                     </a:p>
                   </a:txBody>
-                  <a:tcPr marL="26719" marR="26719" marT="13359" marB="13359" anchor="ctr"/>
+                  <a:tcPr marL="28085" marR="28085" marT="14042" marB="14042" anchor="ctr"/>
                 </a:tc>
                 <a:extLst>
                   <a:ext uri="{0D108BD9-81ED-4DB2-BD59-A6C34878D82A}">
@@ -11415,7 +11460,7 @@
                   </a:ext>
                 </a:extLst>
               </a:tr>
-              <a:tr h="658594">
+              <a:tr h="691268">
                 <a:tc>
                   <a:txBody>
                     <a:bodyPr/>
@@ -11430,18 +11475,18 @@
                         </a:spcAft>
                       </a:pPr>
                       <a:r>
-                        <a:rPr lang="en-US" sz="1300" b="0" u="none" strike="noStrike">
+                        <a:rPr lang="en-US" sz="1400" b="0" u="none" strike="noStrike">
                           <a:effectLst/>
                         </a:rPr>
                         <a:t>Staff</a:t>
                       </a:r>
-                      <a:endParaRPr lang="en-US" altLang="zh-HK" sz="1300" b="0" i="0" u="none" strike="noStrike">
+                      <a:endParaRPr lang="en-US" altLang="zh-HK" sz="1400" b="0" i="0" u="none" strike="noStrike">
                         <a:effectLst/>
                         <a:latin typeface="Arial" panose="020B0604020202020204" pitchFamily="34" charset="0"/>
                       </a:endParaRPr>
                     </a:p>
                   </a:txBody>
-                  <a:tcPr marL="26719" marR="26719" marT="13359" marB="13359" anchor="ctr"/>
+                  <a:tcPr marL="28085" marR="28085" marT="14042" marB="14042" anchor="ctr"/>
                 </a:tc>
                 <a:tc>
                   <a:txBody>
@@ -11457,7 +11502,7 @@
                         </a:spcAft>
                       </a:pPr>
                       <a:r>
-                        <a:rPr lang="zh-HK" altLang="en-US" sz="1300" b="0" u="none" strike="noStrike" dirty="0">
+                        <a:rPr lang="zh-HK" altLang="en-US" sz="1400" b="0" u="none" strike="noStrike">
                           <a:solidFill>
                             <a:srgbClr val="FFD700"/>
                           </a:solidFill>
@@ -11465,7 +11510,7 @@
                         </a:rPr>
                         <a:t>●</a:t>
                       </a:r>
-                      <a:endParaRPr lang="zh-HK" altLang="en-US" sz="1300" b="0" i="0" u="none" strike="noStrike" dirty="0">
+                      <a:endParaRPr lang="zh-HK" altLang="en-US" sz="1400" b="0" i="0" u="none" strike="noStrike">
                         <a:solidFill>
                           <a:srgbClr val="FFD700"/>
                         </a:solidFill>
@@ -11474,7 +11519,7 @@
                       </a:endParaRPr>
                     </a:p>
                   </a:txBody>
-                  <a:tcPr marL="26719" marR="26719" marT="13359" marB="13359" anchor="ctr"/>
+                  <a:tcPr marL="28085" marR="28085" marT="14042" marB="14042" anchor="ctr"/>
                 </a:tc>
                 <a:tc>
                   <a:txBody>
@@ -11490,18 +11535,18 @@
                         </a:spcAft>
                       </a:pPr>
                       <a:r>
-                        <a:rPr lang="en-US" sz="1300" b="0" u="none" strike="noStrike" dirty="0">
+                        <a:rPr lang="en-US" sz="1400" b="0" u="none" strike="noStrike">
                           <a:effectLst/>
                         </a:rPr>
                         <a:t>Dagmar Hilgard should be more careful with hiring high-level positions. Ed Claiborne is acceptable, but not the most suitable for the position in the company. The position could had been held by a better person.</a:t>
                       </a:r>
-                      <a:endParaRPr lang="en-US" altLang="zh-HK" sz="1300" b="0" i="0" u="none" strike="noStrike" dirty="0">
+                      <a:endParaRPr lang="en-US" altLang="zh-HK" sz="1400" b="0" i="0" u="none" strike="noStrike">
                         <a:effectLst/>
                         <a:latin typeface="Arial" panose="020B0604020202020204" pitchFamily="34" charset="0"/>
                       </a:endParaRPr>
                     </a:p>
                   </a:txBody>
-                  <a:tcPr marL="26719" marR="26719" marT="13359" marB="13359" anchor="ctr"/>
+                  <a:tcPr marL="28085" marR="28085" marT="14042" marB="14042" anchor="ctr"/>
                 </a:tc>
                 <a:extLst>
                   <a:ext uri="{0D108BD9-81ED-4DB2-BD59-A6C34878D82A}">
@@ -11509,7 +11554,7 @@
                   </a:ext>
                 </a:extLst>
               </a:tr>
-              <a:tr h="460179">
+              <a:tr h="483022">
                 <a:tc>
                   <a:txBody>
                     <a:bodyPr/>
@@ -11524,18 +11569,18 @@
                         </a:spcAft>
                       </a:pPr>
                       <a:r>
-                        <a:rPr lang="en-US" sz="1300" b="0" u="none" strike="noStrike">
+                        <a:rPr lang="en-US" sz="1400" b="0" u="none" strike="noStrike">
                           <a:effectLst/>
                         </a:rPr>
                         <a:t>Skills</a:t>
                       </a:r>
-                      <a:endParaRPr lang="en-US" altLang="zh-HK" sz="1300" b="0" i="0" u="none" strike="noStrike">
+                      <a:endParaRPr lang="en-US" altLang="zh-HK" sz="1400" b="0" i="0" u="none" strike="noStrike">
                         <a:effectLst/>
                         <a:latin typeface="Arial" panose="020B0604020202020204" pitchFamily="34" charset="0"/>
                       </a:endParaRPr>
                     </a:p>
                   </a:txBody>
-                  <a:tcPr marL="26719" marR="26719" marT="13359" marB="13359" anchor="ctr"/>
+                  <a:tcPr marL="28085" marR="28085" marT="14042" marB="14042" anchor="ctr"/>
                 </a:tc>
                 <a:tc>
                   <a:txBody>
@@ -11551,7 +11596,7 @@
                         </a:spcAft>
                       </a:pPr>
                       <a:r>
-                        <a:rPr lang="zh-HK" altLang="en-US" sz="1300" b="0" u="none" strike="noStrike">
+                        <a:rPr lang="zh-HK" altLang="en-US" sz="1400" b="0" u="none" strike="noStrike">
                           <a:solidFill>
                             <a:srgbClr val="FF0000"/>
                           </a:solidFill>
@@ -11559,13 +11604,13 @@
                         </a:rPr>
                         <a:t>●</a:t>
                       </a:r>
-                      <a:endParaRPr lang="zh-HK" altLang="en-US" sz="1300" b="0" i="0" u="none" strike="noStrike">
+                      <a:endParaRPr lang="zh-HK" altLang="en-US" sz="1400" b="0" i="0" u="none" strike="noStrike">
                         <a:effectLst/>
                         <a:latin typeface="Arial" panose="020B0604020202020204" pitchFamily="34" charset="0"/>
                       </a:endParaRPr>
                     </a:p>
                   </a:txBody>
-                  <a:tcPr marL="26719" marR="26719" marT="13359" marB="13359" anchor="ctr"/>
+                  <a:tcPr marL="28085" marR="28085" marT="14042" marB="14042" anchor="ctr"/>
                 </a:tc>
                 <a:tc>
                   <a:txBody>
@@ -11581,18 +11626,18 @@
                         </a:spcAft>
                       </a:pPr>
                       <a:r>
-                        <a:rPr lang="en-US" sz="1300" b="0" u="none" strike="noStrike">
+                        <a:rPr lang="en-US" sz="1400" b="0" u="none" strike="noStrike">
                           <a:effectLst/>
                         </a:rPr>
                         <a:t>There is almost no onboarding for Ed Claiborne for holding such a high-level position. Ed Claiborne went straight into the work without learning about the company structure at all.</a:t>
                       </a:r>
-                      <a:endParaRPr lang="en-US" altLang="zh-HK" sz="1300" b="0" i="0" u="none" strike="noStrike">
+                      <a:endParaRPr lang="en-US" altLang="zh-HK" sz="1400" b="0" i="0" u="none" strike="noStrike">
                         <a:effectLst/>
                         <a:latin typeface="Arial" panose="020B0604020202020204" pitchFamily="34" charset="0"/>
                       </a:endParaRPr>
                     </a:p>
                   </a:txBody>
-                  <a:tcPr marL="26719" marR="26719" marT="13359" marB="13359" anchor="ctr"/>
+                  <a:tcPr marL="28085" marR="28085" marT="14042" marB="14042" anchor="ctr"/>
                 </a:tc>
                 <a:extLst>
                   <a:ext uri="{0D108BD9-81ED-4DB2-BD59-A6C34878D82A}">
@@ -11600,7 +11645,7 @@
                   </a:ext>
                 </a:extLst>
               </a:tr>
-              <a:tr h="658594">
+              <a:tr h="691268">
                 <a:tc>
                   <a:txBody>
                     <a:bodyPr/>
@@ -11615,18 +11660,18 @@
                         </a:spcAft>
                       </a:pPr>
                       <a:r>
-                        <a:rPr lang="en-US" sz="1300" b="0" u="none" strike="noStrike">
+                        <a:rPr lang="en-US" sz="1400" b="0" u="none" strike="noStrike">
                           <a:effectLst/>
                         </a:rPr>
                         <a:t>Structure</a:t>
                       </a:r>
-                      <a:endParaRPr lang="en-US" altLang="zh-HK" sz="1300" b="0" i="0" u="none" strike="noStrike">
+                      <a:endParaRPr lang="en-US" altLang="zh-HK" sz="1400" b="0" i="0" u="none" strike="noStrike">
                         <a:effectLst/>
                         <a:latin typeface="Arial" panose="020B0604020202020204" pitchFamily="34" charset="0"/>
                       </a:endParaRPr>
                     </a:p>
                   </a:txBody>
-                  <a:tcPr marL="26719" marR="26719" marT="13359" marB="13359" anchor="ctr"/>
+                  <a:tcPr marL="28085" marR="28085" marT="14042" marB="14042" anchor="ctr"/>
                 </a:tc>
                 <a:tc>
                   <a:txBody>
@@ -11642,7 +11687,7 @@
                         </a:spcAft>
                       </a:pPr>
                       <a:r>
-                        <a:rPr lang="zh-HK" altLang="en-US" sz="1300" b="0" u="none" strike="noStrike" dirty="0">
+                        <a:rPr lang="zh-HK" altLang="en-US" sz="1400" b="0" u="none" strike="noStrike">
                           <a:solidFill>
                             <a:srgbClr val="FFD700"/>
                           </a:solidFill>
@@ -11650,7 +11695,7 @@
                         </a:rPr>
                         <a:t>●</a:t>
                       </a:r>
-                      <a:endParaRPr lang="zh-HK" altLang="en-US" sz="1300" b="0" i="0" u="none" strike="noStrike" dirty="0">
+                      <a:endParaRPr lang="zh-HK" altLang="en-US" sz="1400" b="0" i="0" u="none" strike="noStrike">
                         <a:solidFill>
                           <a:srgbClr val="FFD700"/>
                         </a:solidFill>
@@ -11659,7 +11704,7 @@
                       </a:endParaRPr>
                     </a:p>
                   </a:txBody>
-                  <a:tcPr marL="26719" marR="26719" marT="13359" marB="13359" anchor="ctr"/>
+                  <a:tcPr marL="28085" marR="28085" marT="14042" marB="14042" anchor="ctr"/>
                 </a:tc>
                 <a:tc>
                   <a:txBody>
@@ -11675,18 +11720,18 @@
                         </a:spcAft>
                       </a:pPr>
                       <a:r>
-                        <a:rPr lang="en-US" sz="1300" b="0" u="none" strike="noStrike">
+                        <a:rPr lang="en-US" sz="1400" b="0" u="none" strike="noStrike">
                           <a:effectLst/>
                         </a:rPr>
                         <a:t>The newly added Corporate Vice President of Procurement is not placed at the right position of the company structure. This is understandable, given that the position is new and reorganization takes time.</a:t>
                       </a:r>
-                      <a:endParaRPr lang="en-US" altLang="zh-HK" sz="1300" b="0" i="0" u="none" strike="noStrike">
+                      <a:endParaRPr lang="en-US" altLang="zh-HK" sz="1400" b="0" i="0" u="none" strike="noStrike">
                         <a:effectLst/>
                         <a:latin typeface="Arial" panose="020B0604020202020204" pitchFamily="34" charset="0"/>
                       </a:endParaRPr>
                     </a:p>
                   </a:txBody>
-                  <a:tcPr marL="26719" marR="26719" marT="13359" marB="13359" anchor="ctr"/>
+                  <a:tcPr marL="28085" marR="28085" marT="14042" marB="14042" anchor="ctr"/>
                 </a:tc>
                 <a:extLst>
                   <a:ext uri="{0D108BD9-81ED-4DB2-BD59-A6C34878D82A}">
@@ -11694,7 +11739,7 @@
                   </a:ext>
                 </a:extLst>
               </a:tr>
-              <a:tr h="460179">
+              <a:tr h="483022">
                 <a:tc>
                   <a:txBody>
                     <a:bodyPr/>
@@ -11709,18 +11754,18 @@
                         </a:spcAft>
                       </a:pPr>
                       <a:r>
-                        <a:rPr lang="en-US" sz="1300" b="0" u="none" strike="noStrike">
+                        <a:rPr lang="en-US" sz="1400" b="0" u="none" strike="noStrike">
                           <a:effectLst/>
                         </a:rPr>
                         <a:t>System</a:t>
                       </a:r>
-                      <a:endParaRPr lang="en-US" altLang="zh-HK" sz="1300" b="0" i="0" u="none" strike="noStrike">
+                      <a:endParaRPr lang="en-US" altLang="zh-HK" sz="1400" b="0" i="0" u="none" strike="noStrike">
                         <a:effectLst/>
                         <a:latin typeface="Arial" panose="020B0604020202020204" pitchFamily="34" charset="0"/>
                       </a:endParaRPr>
                     </a:p>
                   </a:txBody>
-                  <a:tcPr marL="26719" marR="26719" marT="13359" marB="13359" anchor="ctr"/>
+                  <a:tcPr marL="28085" marR="28085" marT="14042" marB="14042" anchor="ctr"/>
                 </a:tc>
                 <a:tc>
                   <a:txBody>
@@ -11736,7 +11781,7 @@
                         </a:spcAft>
                       </a:pPr>
                       <a:r>
-                        <a:rPr lang="zh-HK" altLang="en-US" sz="1300" b="0" u="none" strike="noStrike">
+                        <a:rPr lang="zh-HK" altLang="en-US" sz="1400" b="0" u="none" strike="noStrike">
                           <a:solidFill>
                             <a:srgbClr val="FF0000"/>
                           </a:solidFill>
@@ -11744,13 +11789,13 @@
                         </a:rPr>
                         <a:t>●</a:t>
                       </a:r>
-                      <a:endParaRPr lang="zh-HK" altLang="en-US" sz="1300" b="0" i="0" u="none" strike="noStrike">
+                      <a:endParaRPr lang="zh-HK" altLang="en-US" sz="1400" b="0" i="0" u="none" strike="noStrike">
                         <a:effectLst/>
                         <a:latin typeface="Arial" panose="020B0604020202020204" pitchFamily="34" charset="0"/>
                       </a:endParaRPr>
                     </a:p>
                   </a:txBody>
-                  <a:tcPr marL="26719" marR="26719" marT="13359" marB="13359" anchor="ctr"/>
+                  <a:tcPr marL="28085" marR="28085" marT="14042" marB="14042" anchor="ctr"/>
                 </a:tc>
                 <a:tc>
                   <a:txBody>
@@ -11766,18 +11811,18 @@
                         </a:spcAft>
                       </a:pPr>
                       <a:r>
-                        <a:rPr lang="en-US" sz="1300" b="0" u="none" strike="noStrike">
+                        <a:rPr lang="en-US" sz="1400" b="0" u="none" strike="noStrike">
                           <a:effectLst/>
                         </a:rPr>
                         <a:t>There is little technology in coordinating activities between plants. It shows the company should put a lot of resources into internal infrastructure to improve its operational efficiency.</a:t>
                       </a:r>
-                      <a:endParaRPr lang="en-US" altLang="zh-HK" sz="1300" b="0" i="0" u="none" strike="noStrike">
+                      <a:endParaRPr lang="en-US" altLang="zh-HK" sz="1400" b="0" i="0" u="none" strike="noStrike">
                         <a:effectLst/>
                         <a:latin typeface="Arial" panose="020B0604020202020204" pitchFamily="34" charset="0"/>
                       </a:endParaRPr>
                     </a:p>
                   </a:txBody>
-                  <a:tcPr marL="26719" marR="26719" marT="13359" marB="13359" anchor="ctr"/>
+                  <a:tcPr marL="28085" marR="28085" marT="14042" marB="14042" anchor="ctr"/>
                 </a:tc>
                 <a:extLst>
                   <a:ext uri="{0D108BD9-81ED-4DB2-BD59-A6C34878D82A}">
@@ -11785,7 +11830,7 @@
                   </a:ext>
                 </a:extLst>
               </a:tr>
-              <a:tr h="460179">
+              <a:tr h="483022">
                 <a:tc>
                   <a:txBody>
                     <a:bodyPr/>
@@ -11800,18 +11845,18 @@
                         </a:spcAft>
                       </a:pPr>
                       <a:r>
-                        <a:rPr lang="en-US" sz="1300" b="0" u="none" strike="noStrike">
+                        <a:rPr lang="en-US" sz="1400" b="0" u="none" strike="noStrike">
                           <a:effectLst/>
                         </a:rPr>
                         <a:t>Style</a:t>
                       </a:r>
-                      <a:endParaRPr lang="en-US" altLang="zh-HK" sz="1300" b="0" i="0" u="none" strike="noStrike">
+                      <a:endParaRPr lang="en-US" altLang="zh-HK" sz="1400" b="0" i="0" u="none" strike="noStrike">
                         <a:effectLst/>
                         <a:latin typeface="Arial" panose="020B0604020202020204" pitchFamily="34" charset="0"/>
                       </a:endParaRPr>
                     </a:p>
                   </a:txBody>
-                  <a:tcPr marL="26719" marR="26719" marT="13359" marB="13359" anchor="ctr"/>
+                  <a:tcPr marL="28085" marR="28085" marT="14042" marB="14042" anchor="ctr"/>
                 </a:tc>
                 <a:tc>
                   <a:txBody>
@@ -11827,7 +11872,7 @@
                         </a:spcAft>
                       </a:pPr>
                       <a:r>
-                        <a:rPr lang="zh-HK" altLang="en-US" sz="1300" b="0" u="none" strike="noStrike">
+                        <a:rPr lang="zh-HK" altLang="en-US" sz="1400" b="0" u="none" strike="noStrike">
                           <a:solidFill>
                             <a:srgbClr val="008000"/>
                           </a:solidFill>
@@ -11835,13 +11880,13 @@
                         </a:rPr>
                         <a:t>●</a:t>
                       </a:r>
-                      <a:endParaRPr lang="zh-HK" altLang="en-US" sz="1300" b="0" i="0" u="none" strike="noStrike">
+                      <a:endParaRPr lang="zh-HK" altLang="en-US" sz="1400" b="0" i="0" u="none" strike="noStrike">
                         <a:effectLst/>
                         <a:latin typeface="Arial" panose="020B0604020202020204" pitchFamily="34" charset="0"/>
                       </a:endParaRPr>
                     </a:p>
                   </a:txBody>
-                  <a:tcPr marL="26719" marR="26719" marT="13359" marB="13359" anchor="ctr"/>
+                  <a:tcPr marL="28085" marR="28085" marT="14042" marB="14042" anchor="ctr"/>
                 </a:tc>
                 <a:tc>
                   <a:txBody>
@@ -11857,18 +11902,18 @@
                         </a:spcAft>
                       </a:pPr>
                       <a:r>
-                        <a:rPr lang="en-US" sz="1300" b="0" u="none" strike="noStrike">
+                        <a:rPr lang="en-US" sz="1400" b="0" u="none" strike="noStrike">
                           <a:effectLst/>
                         </a:rPr>
                         <a:t>The company management is consistent with its shared values. That plant managers do not respect Ed Claiborne is a natural result of this management style.</a:t>
                       </a:r>
-                      <a:endParaRPr lang="en-US" altLang="zh-HK" sz="1300" b="0" i="0" u="none" strike="noStrike">
+                      <a:endParaRPr lang="en-US" altLang="zh-HK" sz="1400" b="0" i="0" u="none" strike="noStrike">
                         <a:effectLst/>
                         <a:latin typeface="Arial" panose="020B0604020202020204" pitchFamily="34" charset="0"/>
                       </a:endParaRPr>
                     </a:p>
                   </a:txBody>
-                  <a:tcPr marL="26719" marR="26719" marT="13359" marB="13359" anchor="ctr"/>
+                  <a:tcPr marL="28085" marR="28085" marT="14042" marB="14042" anchor="ctr"/>
                 </a:tc>
                 <a:extLst>
                   <a:ext uri="{0D108BD9-81ED-4DB2-BD59-A6C34878D82A}">
@@ -11876,7 +11921,7 @@
                   </a:ext>
                 </a:extLst>
               </a:tr>
-              <a:tr h="460179">
+              <a:tr h="483022">
                 <a:tc>
                   <a:txBody>
                     <a:bodyPr/>
@@ -11891,18 +11936,18 @@
                         </a:spcAft>
                       </a:pPr>
                       <a:r>
-                        <a:rPr lang="en-US" sz="1300" b="0" u="none" strike="noStrike">
+                        <a:rPr lang="en-US" sz="1400" b="0" u="none" strike="noStrike">
                           <a:effectLst/>
                         </a:rPr>
                         <a:t>Shared values</a:t>
                       </a:r>
-                      <a:endParaRPr lang="en-US" altLang="zh-HK" sz="1300" b="0" i="0" u="none" strike="noStrike">
+                      <a:endParaRPr lang="en-US" altLang="zh-HK" sz="1400" b="0" i="0" u="none" strike="noStrike">
                         <a:effectLst/>
                         <a:latin typeface="Arial" panose="020B0604020202020204" pitchFamily="34" charset="0"/>
                       </a:endParaRPr>
                     </a:p>
                   </a:txBody>
-                  <a:tcPr marL="26719" marR="26719" marT="13359" marB="13359" anchor="ctr"/>
+                  <a:tcPr marL="28085" marR="28085" marT="14042" marB="14042" anchor="ctr"/>
                 </a:tc>
                 <a:tc>
                   <a:txBody>
@@ -11918,7 +11963,7 @@
                         </a:spcAft>
                       </a:pPr>
                       <a:r>
-                        <a:rPr lang="zh-HK" altLang="en-US" sz="1300" b="0" u="none" strike="noStrike">
+                        <a:rPr lang="zh-HK" altLang="en-US" sz="1400" b="0" u="none" strike="noStrike">
                           <a:solidFill>
                             <a:srgbClr val="008000"/>
                           </a:solidFill>
@@ -11926,13 +11971,13 @@
                         </a:rPr>
                         <a:t>●</a:t>
                       </a:r>
-                      <a:endParaRPr lang="zh-HK" altLang="en-US" sz="1300" b="0" i="0" u="none" strike="noStrike">
+                      <a:endParaRPr lang="zh-HK" altLang="en-US" sz="1400" b="0" i="0" u="none" strike="noStrike">
                         <a:effectLst/>
                         <a:latin typeface="Arial" panose="020B0604020202020204" pitchFamily="34" charset="0"/>
                       </a:endParaRPr>
                     </a:p>
                   </a:txBody>
-                  <a:tcPr marL="26719" marR="26719" marT="13359" marB="13359" anchor="ctr"/>
+                  <a:tcPr marL="28085" marR="28085" marT="14042" marB="14042" anchor="ctr"/>
                 </a:tc>
                 <a:tc>
                   <a:txBody>
@@ -11948,18 +11993,18 @@
                         </a:spcAft>
                       </a:pPr>
                       <a:r>
-                        <a:rPr lang="en-US" sz="1300" b="0" u="none" strike="noStrike" dirty="0">
+                        <a:rPr lang="en-US" sz="1400" b="0" u="none" strike="noStrike">
                           <a:effectLst/>
                         </a:rPr>
                         <a:t>There is nothing inherently wrong with autonomy and decentralization. Furthermore, only Ed Claiborne is incompatible with the shared values in the situation.</a:t>
                       </a:r>
-                      <a:endParaRPr lang="en-US" altLang="zh-HK" sz="1300" b="0" i="0" u="none" strike="noStrike" dirty="0">
+                      <a:endParaRPr lang="en-US" altLang="zh-HK" sz="1400" b="0" i="0" u="none" strike="noStrike">
                         <a:effectLst/>
                         <a:latin typeface="Arial" panose="020B0604020202020204" pitchFamily="34" charset="0"/>
                       </a:endParaRPr>
                     </a:p>
                   </a:txBody>
-                  <a:tcPr marL="26719" marR="26719" marT="13359" marB="13359" anchor="ctr"/>
+                  <a:tcPr marL="28085" marR="28085" marT="14042" marB="14042" anchor="ctr"/>
                 </a:tc>
                 <a:extLst>
                   <a:ext uri="{0D108BD9-81ED-4DB2-BD59-A6C34878D82A}">

</xml_diff>